<commit_message>
augment data pipline / data added
</commit_message>
<xml_diff>
--- a/Report/MP_24MCD009.pptx
+++ b/Report/MP_24MCD009.pptx
@@ -5,7 +5,7 @@
     <p:sldMasterId id="2147483659" r:id="rId1"/>
   </p:sldMasterIdLst>
   <p:notesMasterIdLst>
-    <p:notesMasterId r:id="rId24"/>
+    <p:notesMasterId r:id="rId25"/>
   </p:notesMasterIdLst>
   <p:sldIdLst>
     <p:sldId id="256" r:id="rId2"/>
@@ -21,15 +21,16 @@
     <p:sldId id="277" r:id="rId12"/>
     <p:sldId id="262" r:id="rId13"/>
     <p:sldId id="263" r:id="rId14"/>
-    <p:sldId id="264" r:id="rId15"/>
-    <p:sldId id="265" r:id="rId16"/>
-    <p:sldId id="266" r:id="rId17"/>
-    <p:sldId id="272" r:id="rId18"/>
-    <p:sldId id="271" r:id="rId19"/>
-    <p:sldId id="267" r:id="rId20"/>
-    <p:sldId id="270" r:id="rId21"/>
-    <p:sldId id="268" r:id="rId22"/>
-    <p:sldId id="269" r:id="rId23"/>
+    <p:sldId id="280" r:id="rId15"/>
+    <p:sldId id="281" r:id="rId16"/>
+    <p:sldId id="265" r:id="rId17"/>
+    <p:sldId id="266" r:id="rId18"/>
+    <p:sldId id="272" r:id="rId19"/>
+    <p:sldId id="271" r:id="rId20"/>
+    <p:sldId id="267" r:id="rId21"/>
+    <p:sldId id="270" r:id="rId22"/>
+    <p:sldId id="268" r:id="rId23"/>
+    <p:sldId id="269" r:id="rId24"/>
   </p:sldIdLst>
   <p:sldSz cx="9144000" cy="5143500" type="screen16x9"/>
   <p:notesSz cx="6858000" cy="9144000"/>
@@ -895,110 +896,6 @@
   <p:cSld>
     <p:spTree>
       <p:nvGrpSpPr>
-        <p:cNvPr id="1" name="Shape 111"/>
-        <p:cNvGrpSpPr/>
-        <p:nvPr/>
-      </p:nvGrpSpPr>
-      <p:grpSpPr>
-        <a:xfrm>
-          <a:off x="0" y="0"/>
-          <a:ext cx="0" cy="0"/>
-          <a:chOff x="0" y="0"/>
-          <a:chExt cx="0" cy="0"/>
-        </a:xfrm>
-      </p:grpSpPr>
-      <p:sp>
-        <p:nvSpPr>
-          <p:cNvPr id="112" name="Google Shape;112;g3aedca49173_0_70:notes"/>
-          <p:cNvSpPr>
-            <a:spLocks noGrp="1" noRot="1" noChangeAspect="1"/>
-          </p:cNvSpPr>
-          <p:nvPr>
-            <p:ph type="sldImg" idx="2"/>
-          </p:nvPr>
-        </p:nvSpPr>
-        <p:spPr>
-          <a:xfrm>
-            <a:off x="381000" y="685800"/>
-            <a:ext cx="6096000" cy="3429000"/>
-          </a:xfrm>
-          <a:custGeom>
-            <a:avLst/>
-            <a:gdLst/>
-            <a:ahLst/>
-            <a:cxnLst/>
-            <a:rect l="l" t="t" r="r" b="b"/>
-            <a:pathLst>
-              <a:path w="120000" h="120000" extrusionOk="0">
-                <a:moveTo>
-                  <a:pt x="0" y="0"/>
-                </a:moveTo>
-                <a:lnTo>
-                  <a:pt x="120000" y="0"/>
-                </a:lnTo>
-                <a:lnTo>
-                  <a:pt x="120000" y="120000"/>
-                </a:lnTo>
-                <a:lnTo>
-                  <a:pt x="0" y="120000"/>
-                </a:lnTo>
-                <a:close/>
-              </a:path>
-            </a:pathLst>
-          </a:custGeom>
-        </p:spPr>
-      </p:sp>
-      <p:sp>
-        <p:nvSpPr>
-          <p:cNvPr id="113" name="Google Shape;113;g3aedca49173_0_70:notes"/>
-          <p:cNvSpPr txBox="1">
-            <a:spLocks noGrp="1"/>
-          </p:cNvSpPr>
-          <p:nvPr>
-            <p:ph type="body" idx="1"/>
-          </p:nvPr>
-        </p:nvSpPr>
-        <p:spPr>
-          <a:xfrm>
-            <a:off x="685800" y="4343400"/>
-            <a:ext cx="5486400" cy="4114800"/>
-          </a:xfrm>
-          <a:prstGeom prst="rect">
-            <a:avLst/>
-          </a:prstGeom>
-        </p:spPr>
-        <p:txBody>
-          <a:bodyPr spcFirstLastPara="1" wrap="square" lIns="91425" tIns="91425" rIns="91425" bIns="91425" anchor="t" anchorCtr="0">
-            <a:noAutofit/>
-          </a:bodyPr>
-          <a:lstStyle/>
-          <a:p>
-            <a:pPr marL="0" lvl="0" indent="0" algn="l" rtl="0">
-              <a:spcBef>
-                <a:spcPts val="0"/>
-              </a:spcBef>
-              <a:spcAft>
-                <a:spcPts val="0"/>
-              </a:spcAft>
-              <a:buNone/>
-            </a:pPr>
-            <a:endParaRPr/>
-          </a:p>
-        </p:txBody>
-      </p:sp>
-    </p:spTree>
-  </p:cSld>
-  <p:clrMapOvr>
-    <a:masterClrMapping/>
-  </p:clrMapOvr>
-</p:notes>
-</file>
-
-<file path=ppt/notesSlides/notesSlide11.xml><?xml version="1.0" encoding="utf-8"?>
-<p:notes xmlns:a="http://schemas.openxmlformats.org/drawingml/2006/main" xmlns:r="http://schemas.openxmlformats.org/officeDocument/2006/relationships" xmlns:p="http://schemas.openxmlformats.org/presentationml/2006/main" showMasterSp="0" showMasterPhAnim="0">
-  <p:cSld>
-    <p:spTree>
-      <p:nvGrpSpPr>
         <p:cNvPr id="1" name="Shape 117"/>
         <p:cNvGrpSpPr/>
         <p:nvPr/>
@@ -1098,7 +995,7 @@
 </p:notes>
 </file>
 
-<file path=ppt/notesSlides/notesSlide12.xml><?xml version="1.0" encoding="utf-8"?>
+<file path=ppt/notesSlides/notesSlide11.xml><?xml version="1.0" encoding="utf-8"?>
 <p:notes xmlns:a="http://schemas.openxmlformats.org/drawingml/2006/main" xmlns:r="http://schemas.openxmlformats.org/officeDocument/2006/relationships" xmlns:p="http://schemas.openxmlformats.org/presentationml/2006/main" showMasterSp="0" showMasterPhAnim="0">
   <p:cSld>
     <p:spTree>
@@ -1127,7 +1024,7 @@
         </p:nvSpPr>
         <p:spPr>
           <a:xfrm>
-            <a:off x="381300" y="685800"/>
+            <a:off x="381000" y="685800"/>
             <a:ext cx="6096000" cy="3429000"/>
           </a:xfrm>
           <a:custGeom>
@@ -1202,7 +1099,7 @@
 </p:notes>
 </file>
 
-<file path=ppt/notesSlides/notesSlide13.xml><?xml version="1.0" encoding="utf-8"?>
+<file path=ppt/notesSlides/notesSlide12.xml><?xml version="1.0" encoding="utf-8"?>
 <p:notes xmlns:a="http://schemas.openxmlformats.org/drawingml/2006/main" xmlns:r="http://schemas.openxmlformats.org/officeDocument/2006/relationships" xmlns:p="http://schemas.openxmlformats.org/presentationml/2006/main" showMasterSp="0" showMasterPhAnim="0">
   <p:cSld>
     <p:spTree>
@@ -1231,7 +1128,7 @@
         </p:nvSpPr>
         <p:spPr>
           <a:xfrm>
-            <a:off x="381300" y="685800"/>
+            <a:off x="381000" y="685800"/>
             <a:ext cx="6096000" cy="3429000"/>
           </a:xfrm>
           <a:custGeom>
@@ -1670,7 +1567,7 @@
         </p:nvSpPr>
         <p:spPr>
           <a:xfrm>
-            <a:off x="381300" y="685800"/>
+            <a:off x="381000" y="685800"/>
             <a:ext cx="6096000" cy="3429000"/>
           </a:xfrm>
           <a:custGeom>
@@ -1958,110 +1855,6 @@
   <p:cSld>
     <p:spTree>
       <p:nvGrpSpPr>
-        <p:cNvPr id="1" name="Shape 99"/>
-        <p:cNvGrpSpPr/>
-        <p:nvPr/>
-      </p:nvGrpSpPr>
-      <p:grpSpPr>
-        <a:xfrm>
-          <a:off x="0" y="0"/>
-          <a:ext cx="0" cy="0"/>
-          <a:chOff x="0" y="0"/>
-          <a:chExt cx="0" cy="0"/>
-        </a:xfrm>
-      </p:grpSpPr>
-      <p:sp>
-        <p:nvSpPr>
-          <p:cNvPr id="100" name="Google Shape;100;g3aedca49173_0_51:notes"/>
-          <p:cNvSpPr>
-            <a:spLocks noGrp="1" noRot="1" noChangeAspect="1"/>
-          </p:cNvSpPr>
-          <p:nvPr>
-            <p:ph type="sldImg" idx="2"/>
-          </p:nvPr>
-        </p:nvSpPr>
-        <p:spPr>
-          <a:xfrm>
-            <a:off x="381000" y="685800"/>
-            <a:ext cx="6096000" cy="3429000"/>
-          </a:xfrm>
-          <a:custGeom>
-            <a:avLst/>
-            <a:gdLst/>
-            <a:ahLst/>
-            <a:cxnLst/>
-            <a:rect l="l" t="t" r="r" b="b"/>
-            <a:pathLst>
-              <a:path w="120000" h="120000" extrusionOk="0">
-                <a:moveTo>
-                  <a:pt x="0" y="0"/>
-                </a:moveTo>
-                <a:lnTo>
-                  <a:pt x="120000" y="0"/>
-                </a:lnTo>
-                <a:lnTo>
-                  <a:pt x="120000" y="120000"/>
-                </a:lnTo>
-                <a:lnTo>
-                  <a:pt x="0" y="120000"/>
-                </a:lnTo>
-                <a:close/>
-              </a:path>
-            </a:pathLst>
-          </a:custGeom>
-        </p:spPr>
-      </p:sp>
-      <p:sp>
-        <p:nvSpPr>
-          <p:cNvPr id="101" name="Google Shape;101;g3aedca49173_0_51:notes"/>
-          <p:cNvSpPr txBox="1">
-            <a:spLocks noGrp="1"/>
-          </p:cNvSpPr>
-          <p:nvPr>
-            <p:ph type="body" idx="1"/>
-          </p:nvPr>
-        </p:nvSpPr>
-        <p:spPr>
-          <a:xfrm>
-            <a:off x="685800" y="4343400"/>
-            <a:ext cx="5486400" cy="4114800"/>
-          </a:xfrm>
-          <a:prstGeom prst="rect">
-            <a:avLst/>
-          </a:prstGeom>
-        </p:spPr>
-        <p:txBody>
-          <a:bodyPr spcFirstLastPara="1" wrap="square" lIns="91425" tIns="91425" rIns="91425" bIns="91425" anchor="t" anchorCtr="0">
-            <a:noAutofit/>
-          </a:bodyPr>
-          <a:lstStyle/>
-          <a:p>
-            <a:pPr marL="0" lvl="0" indent="0" algn="l" rtl="0">
-              <a:spcBef>
-                <a:spcPts val="0"/>
-              </a:spcBef>
-              <a:spcAft>
-                <a:spcPts val="0"/>
-              </a:spcAft>
-              <a:buNone/>
-            </a:pPr>
-            <a:endParaRPr/>
-          </a:p>
-        </p:txBody>
-      </p:sp>
-    </p:spTree>
-  </p:cSld>
-  <p:clrMapOvr>
-    <a:masterClrMapping/>
-  </p:clrMapOvr>
-</p:notes>
-</file>
-
-<file path=ppt/notesSlides/notesSlide9.xml><?xml version="1.0" encoding="utf-8"?>
-<p:notes xmlns:a="http://schemas.openxmlformats.org/drawingml/2006/main" xmlns:r="http://schemas.openxmlformats.org/officeDocument/2006/relationships" xmlns:p="http://schemas.openxmlformats.org/presentationml/2006/main" showMasterSp="0" showMasterPhAnim="0">
-  <p:cSld>
-    <p:spTree>
-      <p:nvGrpSpPr>
         <p:cNvPr id="1" name="Shape 105"/>
         <p:cNvGrpSpPr/>
         <p:nvPr/>
@@ -2118,6 +1911,110 @@
       <p:sp>
         <p:nvSpPr>
           <p:cNvPr id="107" name="Google Shape;107;g3aedca49173_0_58:notes"/>
+          <p:cNvSpPr txBox="1">
+            <a:spLocks noGrp="1"/>
+          </p:cNvSpPr>
+          <p:nvPr>
+            <p:ph type="body" idx="1"/>
+          </p:nvPr>
+        </p:nvSpPr>
+        <p:spPr>
+          <a:xfrm>
+            <a:off x="685800" y="4343400"/>
+            <a:ext cx="5486400" cy="4114800"/>
+          </a:xfrm>
+          <a:prstGeom prst="rect">
+            <a:avLst/>
+          </a:prstGeom>
+        </p:spPr>
+        <p:txBody>
+          <a:bodyPr spcFirstLastPara="1" wrap="square" lIns="91425" tIns="91425" rIns="91425" bIns="91425" anchor="t" anchorCtr="0">
+            <a:noAutofit/>
+          </a:bodyPr>
+          <a:lstStyle/>
+          <a:p>
+            <a:pPr marL="0" lvl="0" indent="0" algn="l" rtl="0">
+              <a:spcBef>
+                <a:spcPts val="0"/>
+              </a:spcBef>
+              <a:spcAft>
+                <a:spcPts val="0"/>
+              </a:spcAft>
+              <a:buNone/>
+            </a:pPr>
+            <a:endParaRPr/>
+          </a:p>
+        </p:txBody>
+      </p:sp>
+    </p:spTree>
+  </p:cSld>
+  <p:clrMapOvr>
+    <a:masterClrMapping/>
+  </p:clrMapOvr>
+</p:notes>
+</file>
+
+<file path=ppt/notesSlides/notesSlide9.xml><?xml version="1.0" encoding="utf-8"?>
+<p:notes xmlns:a="http://schemas.openxmlformats.org/drawingml/2006/main" xmlns:r="http://schemas.openxmlformats.org/officeDocument/2006/relationships" xmlns:p="http://schemas.openxmlformats.org/presentationml/2006/main" showMasterSp="0" showMasterPhAnim="0">
+  <p:cSld>
+    <p:spTree>
+      <p:nvGrpSpPr>
+        <p:cNvPr id="1" name="Shape 111"/>
+        <p:cNvGrpSpPr/>
+        <p:nvPr/>
+      </p:nvGrpSpPr>
+      <p:grpSpPr>
+        <a:xfrm>
+          <a:off x="0" y="0"/>
+          <a:ext cx="0" cy="0"/>
+          <a:chOff x="0" y="0"/>
+          <a:chExt cx="0" cy="0"/>
+        </a:xfrm>
+      </p:grpSpPr>
+      <p:sp>
+        <p:nvSpPr>
+          <p:cNvPr id="112" name="Google Shape;112;g3aedca49173_0_70:notes"/>
+          <p:cNvSpPr>
+            <a:spLocks noGrp="1" noRot="1" noChangeAspect="1"/>
+          </p:cNvSpPr>
+          <p:nvPr>
+            <p:ph type="sldImg" idx="2"/>
+          </p:nvPr>
+        </p:nvSpPr>
+        <p:spPr>
+          <a:xfrm>
+            <a:off x="381000" y="685800"/>
+            <a:ext cx="6096000" cy="3429000"/>
+          </a:xfrm>
+          <a:custGeom>
+            <a:avLst/>
+            <a:gdLst/>
+            <a:ahLst/>
+            <a:cxnLst/>
+            <a:rect l="l" t="t" r="r" b="b"/>
+            <a:pathLst>
+              <a:path w="120000" h="120000" extrusionOk="0">
+                <a:moveTo>
+                  <a:pt x="0" y="0"/>
+                </a:moveTo>
+                <a:lnTo>
+                  <a:pt x="120000" y="0"/>
+                </a:lnTo>
+                <a:lnTo>
+                  <a:pt x="120000" y="120000"/>
+                </a:lnTo>
+                <a:lnTo>
+                  <a:pt x="0" y="120000"/>
+                </a:lnTo>
+                <a:close/>
+              </a:path>
+            </a:pathLst>
+          </a:custGeom>
+        </p:spPr>
+      </p:sp>
+      <p:sp>
+        <p:nvSpPr>
+          <p:cNvPr id="113" name="Google Shape;113;g3aedca49173_0_70:notes"/>
           <p:cNvSpPr txBox="1">
             <a:spLocks noGrp="1"/>
           </p:cNvSpPr>
@@ -6962,10 +6859,10 @@
               <a:buNone/>
             </a:pPr>
             <a:r>
-              <a:rPr lang="en-GB" sz="4000" b="1"/>
+              <a:rPr lang="en-GB" sz="4000" b="1" dirty="0"/>
               <a:t>Intelligent Surveillance System</a:t>
             </a:r>
-            <a:endParaRPr sz="4000" b="1"/>
+            <a:endParaRPr sz="4000" b="1" dirty="0"/>
           </a:p>
           <a:p>
             <a:pPr marL="0" lvl="0" indent="0" algn="l" rtl="0">
@@ -6978,10 +6875,10 @@
               <a:buNone/>
             </a:pPr>
             <a:r>
-              <a:rPr lang="en-GB" sz="3000"/>
+              <a:rPr lang="en-GB" sz="3000" dirty="0"/>
               <a:t>Driven by LLM &amp; CV</a:t>
             </a:r>
-            <a:endParaRPr sz="3000"/>
+            <a:endParaRPr sz="3000" dirty="0"/>
           </a:p>
         </p:txBody>
       </p:sp>
@@ -7085,15 +6982,7 @@
             </a:pPr>
             <a:r>
               <a:rPr lang="en-GB" sz="2000" dirty="0"/>
-              <a:t>Guided By: Dr. Gaurang Raval (Associate Professor CSE </a:t>
-            </a:r>
-            <a:r>
-              <a:rPr lang="en-GB" sz="2000" dirty="0" err="1"/>
-              <a:t>Department,ITNU</a:t>
-            </a:r>
-            <a:r>
-              <a:rPr lang="en-GB" sz="2000" dirty="0"/>
-              <a:t>)</a:t>
+              <a:t>Guided By: Dr. Gaurang Raval</a:t>
             </a:r>
             <a:endParaRPr sz="2000" dirty="0"/>
           </a:p>
@@ -7143,15 +7032,15 @@
         <p:spPr/>
         <p:txBody>
           <a:bodyPr>
-            <a:normAutofit fontScale="90000"/>
+            <a:noAutofit/>
           </a:bodyPr>
           <a:lstStyle/>
           <a:p>
             <a:r>
-              <a:rPr lang="en-GB" dirty="0"/>
+              <a:rPr lang="en-GB" b="1" dirty="0"/>
               <a:t>System Flow Overview</a:t>
             </a:r>
-            <a:endParaRPr lang="en-IN" dirty="0"/>
+            <a:endParaRPr lang="en-IN" b="1" dirty="0"/>
           </a:p>
         </p:txBody>
       </p:sp>
@@ -7169,8 +7058,8 @@
         </p:nvSpPr>
         <p:spPr>
           <a:xfrm>
-            <a:off x="520390" y="1427356"/>
-            <a:ext cx="7059946" cy="3512052"/>
+            <a:off x="364273" y="1122556"/>
+            <a:ext cx="8417689" cy="4196020"/>
           </a:xfrm>
           <a:prstGeom prst="rect">
             <a:avLst/>
@@ -7189,14 +7078,14 @@
               </a:lnSpc>
             </a:pPr>
             <a:r>
-              <a:rPr lang="en-IN" sz="1500" b="1" dirty="0">
+              <a:rPr lang="en-IN" sz="1800" b="1" dirty="0">
                 <a:solidFill>
                   <a:schemeClr val="bg2"/>
                 </a:solidFill>
               </a:rPr>
               <a:t>3. Central Database &amp; Storage</a:t>
             </a:r>
-            <a:endParaRPr lang="en-IN" sz="1500" dirty="0">
+            <a:endParaRPr lang="en-IN" sz="1800" dirty="0">
               <a:solidFill>
                 <a:schemeClr val="bg2"/>
               </a:solidFill>
@@ -7209,7 +7098,7 @@
               </a:lnSpc>
             </a:pPr>
             <a:r>
-              <a:rPr lang="en-IN" sz="1500" dirty="0">
+              <a:rPr lang="en-IN" sz="1800" dirty="0">
                 <a:solidFill>
                   <a:schemeClr val="bg2"/>
                 </a:solidFill>
@@ -7224,7 +7113,7 @@
               </a:lnSpc>
             </a:pPr>
             <a:r>
-              <a:rPr lang="en-IN" sz="1500" dirty="0">
+              <a:rPr lang="en-IN" sz="1800" dirty="0">
                 <a:solidFill>
                   <a:schemeClr val="bg2"/>
                 </a:solidFill>
@@ -7239,7 +7128,7 @@
               </a:lnSpc>
             </a:pPr>
             <a:r>
-              <a:rPr lang="en-IN" sz="1500" dirty="0">
+              <a:rPr lang="en-IN" sz="1800" dirty="0">
                 <a:solidFill>
                   <a:schemeClr val="bg2"/>
                 </a:solidFill>
@@ -7253,7 +7142,7 @@
                 <a:spcPct val="150000"/>
               </a:lnSpc>
             </a:pPr>
-            <a:endParaRPr lang="en-IN" sz="1500" dirty="0">
+            <a:endParaRPr lang="en-IN" sz="1800" dirty="0">
               <a:solidFill>
                 <a:schemeClr val="bg2"/>
               </a:solidFill>
@@ -7266,14 +7155,14 @@
               </a:lnSpc>
             </a:pPr>
             <a:r>
-              <a:rPr lang="en-IN" sz="1500" b="1" dirty="0">
+              <a:rPr lang="en-IN" sz="1800" b="1" dirty="0">
                 <a:solidFill>
                   <a:schemeClr val="bg2"/>
                 </a:solidFill>
               </a:rPr>
               <a:t>4. LLM Analytics Layer</a:t>
             </a:r>
-            <a:endParaRPr lang="en-IN" sz="1500" dirty="0">
+            <a:endParaRPr lang="en-IN" sz="1800" dirty="0">
               <a:solidFill>
                 <a:schemeClr val="bg2"/>
               </a:solidFill>
@@ -7286,7 +7175,7 @@
               </a:lnSpc>
             </a:pPr>
             <a:r>
-              <a:rPr lang="en-IN" sz="1500" dirty="0">
+              <a:rPr lang="en-IN" sz="1800" dirty="0">
                 <a:solidFill>
                   <a:schemeClr val="bg2"/>
                 </a:solidFill>
@@ -7301,7 +7190,7 @@
               </a:lnSpc>
             </a:pPr>
             <a:r>
-              <a:rPr lang="en-IN" sz="1500" dirty="0">
+              <a:rPr lang="en-IN" sz="1800" dirty="0">
                 <a:solidFill>
                   <a:schemeClr val="bg2"/>
                 </a:solidFill>
@@ -7316,7 +7205,7 @@
               </a:lnSpc>
             </a:pPr>
             <a:r>
-              <a:rPr lang="en-IN" sz="1500" dirty="0">
+              <a:rPr lang="en-IN" sz="1800" dirty="0">
                 <a:solidFill>
                   <a:schemeClr val="bg2"/>
                 </a:solidFill>
@@ -7330,7 +7219,7 @@
                 <a:spcPct val="150000"/>
               </a:lnSpc>
             </a:pPr>
-            <a:endParaRPr lang="en-IN" sz="1500" dirty="0">
+            <a:endParaRPr lang="en-IN" sz="1800" dirty="0">
               <a:solidFill>
                 <a:schemeClr val="bg2"/>
               </a:solidFill>
@@ -7387,15 +7276,15 @@
         <p:spPr/>
         <p:txBody>
           <a:bodyPr>
-            <a:normAutofit fontScale="90000"/>
+            <a:noAutofit/>
           </a:bodyPr>
           <a:lstStyle/>
           <a:p>
             <a:r>
-              <a:rPr lang="en-GB" dirty="0"/>
+              <a:rPr lang="en-GB" b="1" dirty="0"/>
               <a:t>System Flow Overview</a:t>
             </a:r>
-            <a:endParaRPr lang="en-IN" dirty="0"/>
+            <a:endParaRPr lang="en-IN" b="1" dirty="0"/>
           </a:p>
         </p:txBody>
       </p:sp>
@@ -7677,7 +7566,7 @@
         </p:spPr>
         <p:txBody>
           <a:bodyPr spcFirstLastPara="1" wrap="square" lIns="91425" tIns="91425" rIns="91425" bIns="91425" anchor="t" anchorCtr="0">
-            <a:normAutofit fontScale="90000"/>
+            <a:noAutofit/>
           </a:bodyPr>
           <a:lstStyle/>
           <a:p>
@@ -7691,10 +7580,10 @@
               <a:buNone/>
             </a:pPr>
             <a:r>
-              <a:rPr lang="en-US" dirty="0"/>
+              <a:rPr lang="en-US" b="1" dirty="0"/>
               <a:t>LLM Reasoning</a:t>
             </a:r>
-            <a:endParaRPr dirty="0"/>
+            <a:endParaRPr b="1" dirty="0"/>
           </a:p>
         </p:txBody>
       </p:sp>
@@ -7774,7 +7663,7 @@
         </p:spPr>
         <p:txBody>
           <a:bodyPr spcFirstLastPara="1" wrap="square" lIns="91425" tIns="91425" rIns="91425" bIns="91425" anchor="t" anchorCtr="0">
-            <a:normAutofit fontScale="90000"/>
+            <a:noAutofit/>
           </a:bodyPr>
           <a:lstStyle/>
           <a:p>
@@ -7788,10 +7677,14 @@
               <a:buNone/>
             </a:pPr>
             <a:r>
-              <a:rPr lang="en-GB"/>
-              <a:t>CV Event Detection and Data Pipepline</a:t>
-            </a:r>
-            <a:endParaRPr/>
+              <a:rPr lang="en-GB" b="1" dirty="0"/>
+              <a:t>CV Event Detection and Data </a:t>
+            </a:r>
+            <a:r>
+              <a:rPr lang="en-GB" b="1" dirty="0" err="1"/>
+              <a:t>Pipepline</a:t>
+            </a:r>
+            <a:endParaRPr b="1" dirty="0"/>
           </a:p>
         </p:txBody>
       </p:sp>
@@ -7954,7 +7847,7 @@
   <p:cSld>
     <p:spTree>
       <p:nvGrpSpPr>
-        <p:cNvPr id="1" name="Shape 102"/>
+        <p:cNvPr id="1" name=""/>
         <p:cNvGrpSpPr/>
         <p:nvPr/>
       </p:nvGrpSpPr>
@@ -7968,8 +7861,14 @@
       </p:grpSpPr>
       <p:sp>
         <p:nvSpPr>
-          <p:cNvPr id="103" name="Google Shape;103;p21"/>
-          <p:cNvSpPr txBox="1">
+          <p:cNvPr id="2" name="Title 1">
+            <a:extLst>
+              <a:ext uri="{FF2B5EF4-FFF2-40B4-BE49-F238E27FC236}">
+                <a16:creationId xmlns:a16="http://schemas.microsoft.com/office/drawing/2014/main" id="{9BA89D3F-476A-A4BE-595D-8254B268A9FA}"/>
+              </a:ext>
+            </a:extLst>
+          </p:cNvPr>
+          <p:cNvSpPr>
             <a:spLocks noGrp="1"/>
           </p:cNvSpPr>
           <p:nvPr>
@@ -7978,179 +7877,60 @@
         </p:nvSpPr>
         <p:spPr>
           <a:xfrm>
-            <a:off x="311700" y="445025"/>
+            <a:off x="103543" y="140225"/>
             <a:ext cx="8520600" cy="572700"/>
+          </a:xfrm>
+        </p:spPr>
+        <p:txBody>
+          <a:bodyPr>
+            <a:noAutofit/>
+          </a:bodyPr>
+          <a:lstStyle/>
+          <a:p>
+            <a:r>
+              <a:rPr lang="en-US" b="1" dirty="0"/>
+              <a:t>Demo</a:t>
+            </a:r>
+            <a:endParaRPr lang="en-IN" b="1" dirty="0"/>
+          </a:p>
+        </p:txBody>
+      </p:sp>
+      <p:pic>
+        <p:nvPicPr>
+          <p:cNvPr id="5" name="Picture 4">
+            <a:extLst>
+              <a:ext uri="{FF2B5EF4-FFF2-40B4-BE49-F238E27FC236}">
+                <a16:creationId xmlns:a16="http://schemas.microsoft.com/office/drawing/2014/main" id="{9ECDC4F5-0C40-09F0-D3A3-B538C4349E16}"/>
+              </a:ext>
+            </a:extLst>
+          </p:cNvPr>
+          <p:cNvPicPr>
+            <a:picLocks noChangeAspect="1"/>
+          </p:cNvPicPr>
+          <p:nvPr/>
+        </p:nvPicPr>
+        <p:blipFill>
+          <a:blip r:embed="rId2"/>
+          <a:stretch>
+            <a:fillRect/>
+          </a:stretch>
+        </p:blipFill>
+        <p:spPr>
+          <a:xfrm>
+            <a:off x="0" y="836786"/>
+            <a:ext cx="9144000" cy="4306714"/>
           </a:xfrm>
           <a:prstGeom prst="rect">
             <a:avLst/>
           </a:prstGeom>
         </p:spPr>
-        <p:txBody>
-          <a:bodyPr spcFirstLastPara="1" wrap="square" lIns="91425" tIns="91425" rIns="91425" bIns="91425" anchor="t" anchorCtr="0">
-            <a:normAutofit fontScale="90000"/>
-          </a:bodyPr>
-          <a:lstStyle/>
-          <a:p>
-            <a:pPr marL="0" lvl="0" indent="0" algn="l" rtl="0">
-              <a:lnSpc>
-                <a:spcPct val="115000"/>
-              </a:lnSpc>
-              <a:spcBef>
-                <a:spcPts val="1200"/>
-              </a:spcBef>
-              <a:spcAft>
-                <a:spcPts val="0"/>
-              </a:spcAft>
-              <a:buClr>
-                <a:schemeClr val="dk1"/>
-              </a:buClr>
-              <a:buSzPct val="39285"/>
-              <a:buFont typeface="Arial"/>
-              <a:buNone/>
-            </a:pPr>
-            <a:r>
-              <a:rPr lang="en-GB"/>
-              <a:t>LLM Analytics and Insight Delivery</a:t>
-            </a:r>
-            <a:endParaRPr/>
-          </a:p>
-          <a:p>
-            <a:pPr marL="457200" lvl="0" indent="-291465" algn="l" rtl="0">
-              <a:lnSpc>
-                <a:spcPct val="115000"/>
-              </a:lnSpc>
-              <a:spcBef>
-                <a:spcPts val="1200"/>
-              </a:spcBef>
-              <a:spcAft>
-                <a:spcPts val="0"/>
-              </a:spcAft>
-              <a:buSzPct val="39285"/>
-              <a:buChar char="●"/>
-            </a:pPr>
-            <a:endParaRPr/>
-          </a:p>
-          <a:p>
-            <a:pPr marL="0" lvl="0" indent="0" algn="l" rtl="0">
-              <a:spcBef>
-                <a:spcPts val="1200"/>
-              </a:spcBef>
-              <a:spcAft>
-                <a:spcPts val="0"/>
-              </a:spcAft>
-              <a:buNone/>
-            </a:pPr>
-            <a:endParaRPr/>
-          </a:p>
-        </p:txBody>
-      </p:sp>
-      <p:sp>
-        <p:nvSpPr>
-          <p:cNvPr id="104" name="Google Shape;104;p21"/>
-          <p:cNvSpPr txBox="1">
-            <a:spLocks noGrp="1"/>
-          </p:cNvSpPr>
-          <p:nvPr>
-            <p:ph type="body" idx="1"/>
-          </p:nvPr>
-        </p:nvSpPr>
-        <p:spPr>
-          <a:xfrm>
-            <a:off x="311700" y="1152475"/>
-            <a:ext cx="8520600" cy="3416400"/>
-          </a:xfrm>
-          <a:prstGeom prst="rect">
-            <a:avLst/>
-          </a:prstGeom>
-        </p:spPr>
-        <p:txBody>
-          <a:bodyPr spcFirstLastPara="1" wrap="square" lIns="91425" tIns="91425" rIns="91425" bIns="91425" anchor="t" anchorCtr="0">
-            <a:normAutofit/>
-          </a:bodyPr>
-          <a:lstStyle/>
-          <a:p>
-            <a:pPr marL="457200" lvl="0" indent="-342900" algn="l" rtl="0">
-              <a:lnSpc>
-                <a:spcPct val="150000"/>
-              </a:lnSpc>
-              <a:spcBef>
-                <a:spcPts val="0"/>
-              </a:spcBef>
-              <a:spcAft>
-                <a:spcPts val="0"/>
-              </a:spcAft>
-              <a:buSzPts val="1800"/>
-              <a:buChar char="●"/>
-            </a:pPr>
-            <a:r>
-              <a:rPr lang="en-GB" sz="1500" dirty="0"/>
-              <a:t>LLM translates natural-language queries into structured database queries or filter/aggregation logic; performs temporal and spatial reasoning</a:t>
-            </a:r>
-            <a:endParaRPr sz="1500" dirty="0"/>
-          </a:p>
-          <a:p>
-            <a:pPr marL="457200" lvl="0" indent="-342900" algn="l" rtl="0">
-              <a:lnSpc>
-                <a:spcPct val="150000"/>
-              </a:lnSpc>
-              <a:spcBef>
-                <a:spcPts val="0"/>
-              </a:spcBef>
-              <a:spcAft>
-                <a:spcPts val="0"/>
-              </a:spcAft>
-              <a:buSzPts val="1800"/>
-              <a:buChar char="●"/>
-            </a:pPr>
-            <a:r>
-              <a:rPr lang="en-GB" sz="1500" dirty="0"/>
-              <a:t>Insight generation: temporal patterns (peak hours, anomaly clusters), spatial correlations across cameras, summaries of high-risk or repetitive events</a:t>
-            </a:r>
-            <a:endParaRPr sz="1500" dirty="0"/>
-          </a:p>
-          <a:p>
-            <a:pPr marL="457200" lvl="0" indent="-342900" algn="l" rtl="0">
-              <a:lnSpc>
-                <a:spcPct val="150000"/>
-              </a:lnSpc>
-              <a:spcBef>
-                <a:spcPts val="0"/>
-              </a:spcBef>
-              <a:spcAft>
-                <a:spcPts val="0"/>
-              </a:spcAft>
-              <a:buSzPts val="1800"/>
-              <a:buChar char="●"/>
-            </a:pPr>
-            <a:r>
-              <a:rPr lang="en-GB" sz="1500" dirty="0"/>
-              <a:t>Output formats: textual summaries, tabular reports, data visualizations, event timelines</a:t>
-            </a:r>
-            <a:endParaRPr sz="1500" dirty="0"/>
-          </a:p>
-          <a:p>
-            <a:pPr marL="457200" lvl="0" indent="-342900" algn="l" rtl="0">
-              <a:lnSpc>
-                <a:spcPct val="150000"/>
-              </a:lnSpc>
-              <a:spcBef>
-                <a:spcPts val="0"/>
-              </a:spcBef>
-              <a:spcAft>
-                <a:spcPts val="0"/>
-              </a:spcAft>
-              <a:buSzPts val="1800"/>
-              <a:buChar char="●"/>
-            </a:pPr>
-            <a:r>
-              <a:rPr lang="en-GB" sz="1500" dirty="0"/>
-              <a:t>Implementation outcome: scalable, modular pipeline integrating CV nodes, centralized logs, and LLM analytics to deliver meaningful forensic insights in real-time and historically</a:t>
-            </a:r>
-            <a:endParaRPr sz="1500" dirty="0"/>
-          </a:p>
-        </p:txBody>
-      </p:sp>
+      </p:pic>
     </p:spTree>
+    <p:extLst>
+      <p:ext uri="{BB962C8B-B14F-4D97-AF65-F5344CB8AC3E}">
+        <p14:creationId xmlns:p14="http://schemas.microsoft.com/office/powerpoint/2010/main" val="3359650559"/>
+      </p:ext>
+    </p:extLst>
   </p:cSld>
   <p:clrMapOvr>
     <a:masterClrMapping/>
@@ -8159,6 +7939,242 @@
 </file>
 
 <file path=ppt/slides/slide15.xml><?xml version="1.0" encoding="utf-8"?>
+<p:sld xmlns:a="http://schemas.openxmlformats.org/drawingml/2006/main" xmlns:r="http://schemas.openxmlformats.org/officeDocument/2006/relationships" xmlns:p="http://schemas.openxmlformats.org/presentationml/2006/main">
+  <p:cSld>
+    <p:spTree>
+      <p:nvGrpSpPr>
+        <p:cNvPr id="1" name=""/>
+        <p:cNvGrpSpPr/>
+        <p:nvPr/>
+      </p:nvGrpSpPr>
+      <p:grpSpPr>
+        <a:xfrm>
+          <a:off x="0" y="0"/>
+          <a:ext cx="0" cy="0"/>
+          <a:chOff x="0" y="0"/>
+          <a:chExt cx="0" cy="0"/>
+        </a:xfrm>
+      </p:grpSpPr>
+      <p:sp>
+        <p:nvSpPr>
+          <p:cNvPr id="2" name="Title 1">
+            <a:extLst>
+              <a:ext uri="{FF2B5EF4-FFF2-40B4-BE49-F238E27FC236}">
+                <a16:creationId xmlns:a16="http://schemas.microsoft.com/office/drawing/2014/main" id="{E11CA401-C8CA-E368-9F9F-BEE4B46326AB}"/>
+              </a:ext>
+            </a:extLst>
+          </p:cNvPr>
+          <p:cNvSpPr>
+            <a:spLocks noGrp="1"/>
+          </p:cNvSpPr>
+          <p:nvPr>
+            <p:ph type="title"/>
+          </p:nvPr>
+        </p:nvSpPr>
+        <p:spPr/>
+        <p:txBody>
+          <a:bodyPr>
+            <a:noAutofit/>
+          </a:bodyPr>
+          <a:lstStyle/>
+          <a:p>
+            <a:r>
+              <a:rPr lang="en-US" b="1" dirty="0"/>
+              <a:t>Query Examples</a:t>
+            </a:r>
+            <a:endParaRPr lang="en-IN" b="1" dirty="0"/>
+          </a:p>
+        </p:txBody>
+      </p:sp>
+      <p:sp>
+        <p:nvSpPr>
+          <p:cNvPr id="3" name="TextBox 2">
+            <a:extLst>
+              <a:ext uri="{FF2B5EF4-FFF2-40B4-BE49-F238E27FC236}">
+                <a16:creationId xmlns:a16="http://schemas.microsoft.com/office/drawing/2014/main" id="{E69C2132-BC5A-DA3D-69BC-C7A648129967}"/>
+              </a:ext>
+            </a:extLst>
+          </p:cNvPr>
+          <p:cNvSpPr txBox="1"/>
+          <p:nvPr/>
+        </p:nvSpPr>
+        <p:spPr>
+          <a:xfrm>
+            <a:off x="483220" y="1213129"/>
+            <a:ext cx="8520601" cy="4196020"/>
+          </a:xfrm>
+          <a:prstGeom prst="rect">
+            <a:avLst/>
+          </a:prstGeom>
+          <a:noFill/>
+        </p:spPr>
+        <p:txBody>
+          <a:bodyPr wrap="square" rtlCol="0">
+            <a:spAutoFit/>
+          </a:bodyPr>
+          <a:lstStyle/>
+          <a:p>
+            <a:pPr marL="285750" indent="-285750">
+              <a:lnSpc>
+                <a:spcPct val="150000"/>
+              </a:lnSpc>
+              <a:buFont typeface="Arial" panose="020B0604020202020204" pitchFamily="34" charset="0"/>
+              <a:buChar char="•"/>
+            </a:pPr>
+            <a:r>
+              <a:rPr lang="en-US" sz="1800" dirty="0">
+                <a:solidFill>
+                  <a:schemeClr val="bg2"/>
+                </a:solidFill>
+              </a:rPr>
+              <a:t>Show me the top 3 gates with highest car exit frequency</a:t>
+            </a:r>
+            <a:br>
+              <a:rPr lang="en-US" sz="1800" dirty="0">
+                <a:solidFill>
+                  <a:schemeClr val="bg2"/>
+                </a:solidFill>
+              </a:rPr>
+            </a:br>
+            <a:r>
+              <a:rPr lang="en-US" sz="1800" dirty="0"/>
+              <a:t>Identifies high-traffic exit points to optimize traffic flow and security deployment.</a:t>
+            </a:r>
+            <a:endParaRPr lang="en-US" sz="1800" dirty="0">
+              <a:solidFill>
+                <a:schemeClr val="bg2"/>
+              </a:solidFill>
+            </a:endParaRPr>
+          </a:p>
+          <a:p>
+            <a:pPr marL="285750" indent="-285750">
+              <a:lnSpc>
+                <a:spcPct val="150000"/>
+              </a:lnSpc>
+              <a:buFont typeface="Arial" panose="020B0604020202020204" pitchFamily="34" charset="0"/>
+              <a:buChar char="•"/>
+            </a:pPr>
+            <a:r>
+              <a:rPr lang="en-US" sz="1800" dirty="0">
+                <a:solidFill>
+                  <a:schemeClr val="bg2"/>
+                </a:solidFill>
+              </a:rPr>
+              <a:t>Which locations have the highest person entry count</a:t>
+            </a:r>
+            <a:br>
+              <a:rPr lang="en-US" sz="1800" dirty="0">
+                <a:solidFill>
+                  <a:schemeClr val="bg2"/>
+                </a:solidFill>
+              </a:rPr>
+            </a:br>
+            <a:r>
+              <a:rPr lang="en-US" sz="1800" dirty="0"/>
+              <a:t>Highlights high-footfall areas for crowd management and resource allocation.</a:t>
+            </a:r>
+            <a:endParaRPr lang="en-US" sz="1800" dirty="0">
+              <a:solidFill>
+                <a:schemeClr val="bg2"/>
+              </a:solidFill>
+            </a:endParaRPr>
+          </a:p>
+          <a:p>
+            <a:pPr marL="285750" indent="-285750">
+              <a:lnSpc>
+                <a:spcPct val="150000"/>
+              </a:lnSpc>
+              <a:buFont typeface="Arial" panose="020B0604020202020204" pitchFamily="34" charset="0"/>
+              <a:buChar char="•"/>
+            </a:pPr>
+            <a:r>
+              <a:rPr lang="en-US" sz="1800" dirty="0">
+                <a:solidFill>
+                  <a:schemeClr val="bg2"/>
+                </a:solidFill>
+              </a:rPr>
+              <a:t>Give me an hour-wise distribution of person entries for Platform 2</a:t>
+            </a:r>
+            <a:br>
+              <a:rPr lang="en-US" sz="1800" dirty="0">
+                <a:solidFill>
+                  <a:schemeClr val="bg2"/>
+                </a:solidFill>
+              </a:rPr>
+            </a:br>
+            <a:r>
+              <a:rPr lang="en-US" sz="1800" dirty="0"/>
+              <a:t>Reveals peak and off-peak hours to support efficient scheduling and congestion control.</a:t>
+            </a:r>
+            <a:endParaRPr lang="en-US" sz="1800" dirty="0">
+              <a:solidFill>
+                <a:schemeClr val="bg2"/>
+              </a:solidFill>
+            </a:endParaRPr>
+          </a:p>
+          <a:p>
+            <a:pPr marL="285750" indent="-285750">
+              <a:lnSpc>
+                <a:spcPct val="150000"/>
+              </a:lnSpc>
+              <a:buFont typeface="Arial" panose="020B0604020202020204" pitchFamily="34" charset="0"/>
+              <a:buChar char="•"/>
+            </a:pPr>
+            <a:r>
+              <a:rPr lang="en-US" sz="1800" dirty="0">
+                <a:solidFill>
+                  <a:schemeClr val="bg2"/>
+                </a:solidFill>
+              </a:rPr>
+              <a:t>Show me locations where crowd size exceeded 15 people.</a:t>
+            </a:r>
+            <a:br>
+              <a:rPr lang="en-US" sz="1800" dirty="0">
+                <a:solidFill>
+                  <a:schemeClr val="bg2"/>
+                </a:solidFill>
+              </a:rPr>
+            </a:br>
+            <a:r>
+              <a:rPr lang="en-US" sz="1800" dirty="0"/>
+              <a:t>Detects potential overcrowding zones for safety monitoring and risk prevention.</a:t>
+            </a:r>
+            <a:endParaRPr lang="en-US" sz="1800" dirty="0">
+              <a:solidFill>
+                <a:schemeClr val="bg2"/>
+              </a:solidFill>
+            </a:endParaRPr>
+          </a:p>
+          <a:p>
+            <a:pPr marL="285750" indent="-285750">
+              <a:lnSpc>
+                <a:spcPct val="150000"/>
+              </a:lnSpc>
+              <a:buFont typeface="Arial" panose="020B0604020202020204" pitchFamily="34" charset="0"/>
+              <a:buChar char="•"/>
+            </a:pPr>
+            <a:endParaRPr lang="en-IN" sz="1800" dirty="0">
+              <a:solidFill>
+                <a:schemeClr val="bg2"/>
+              </a:solidFill>
+            </a:endParaRPr>
+          </a:p>
+        </p:txBody>
+      </p:sp>
+    </p:spTree>
+    <p:extLst>
+      <p:ext uri="{BB962C8B-B14F-4D97-AF65-F5344CB8AC3E}">
+        <p14:creationId xmlns:p14="http://schemas.microsoft.com/office/powerpoint/2010/main" val="3981053208"/>
+      </p:ext>
+    </p:extLst>
+  </p:cSld>
+  <p:clrMapOvr>
+    <a:masterClrMapping/>
+  </p:clrMapOvr>
+</p:sld>
+</file>
+
+<file path=ppt/slides/slide16.xml><?xml version="1.0" encoding="utf-8"?>
 <p:sld xmlns:a="http://schemas.openxmlformats.org/drawingml/2006/main" xmlns:r="http://schemas.openxmlformats.org/officeDocument/2006/relationships" xmlns:p="http://schemas.openxmlformats.org/presentationml/2006/main">
   <p:cSld>
     <p:spTree>
@@ -8196,7 +8212,7 @@
         </p:spPr>
         <p:txBody>
           <a:bodyPr spcFirstLastPara="1" wrap="square" lIns="91425" tIns="91425" rIns="91425" bIns="91425" anchor="t" anchorCtr="0">
-            <a:normAutofit fontScale="90000"/>
+            <a:noAutofit/>
           </a:bodyPr>
           <a:lstStyle/>
           <a:p>
@@ -8213,10 +8229,10 @@
               <a:buNone/>
             </a:pPr>
             <a:r>
-              <a:rPr lang="en-GB"/>
+              <a:rPr lang="en-GB" b="1" dirty="0"/>
               <a:t>Future Scopes</a:t>
             </a:r>
-            <a:endParaRPr/>
+            <a:endParaRPr b="1" dirty="0"/>
           </a:p>
           <a:p>
             <a:pPr marL="457200" lvl="0" indent="-291465" algn="l" rtl="0">
@@ -8232,7 +8248,7 @@
               <a:buSzPct val="39285"/>
               <a:buChar char="●"/>
             </a:pPr>
-            <a:endParaRPr/>
+            <a:endParaRPr dirty="0"/>
           </a:p>
           <a:p>
             <a:pPr marL="0" lvl="0" indent="0" algn="l" rtl="0">
@@ -8244,7 +8260,7 @@
               </a:spcAft>
               <a:buNone/>
             </a:pPr>
-            <a:endParaRPr/>
+            <a:endParaRPr dirty="0"/>
           </a:p>
         </p:txBody>
       </p:sp>
@@ -8287,10 +8303,10 @@
               <a:buChar char="●"/>
             </a:pPr>
             <a:r>
-              <a:rPr lang="en-GB" sz="1500" dirty="0"/>
+              <a:rPr lang="en-GB" dirty="0"/>
               <a:t>Fine-tuned LLMs for Surveillance Reasoning</a:t>
             </a:r>
-            <a:endParaRPr sz="1500" dirty="0"/>
+            <a:endParaRPr dirty="0"/>
           </a:p>
           <a:p>
             <a:pPr marL="457200" lvl="0" indent="-342900" algn="l" rtl="0">
@@ -8307,10 +8323,10 @@
               <a:buChar char="●"/>
             </a:pPr>
             <a:r>
-              <a:rPr lang="en-GB" sz="1500" dirty="0"/>
+              <a:rPr lang="en-GB" dirty="0"/>
               <a:t>Advanced Query Translation and SQL Generation</a:t>
             </a:r>
-            <a:endParaRPr sz="1500" dirty="0"/>
+            <a:endParaRPr dirty="0"/>
           </a:p>
           <a:p>
             <a:pPr marL="457200" lvl="0" indent="-342900" algn="l" rtl="0">
@@ -8327,7 +8343,7 @@
               <a:buChar char="●"/>
             </a:pPr>
             <a:r>
-              <a:rPr lang="en-GB" sz="1500" dirty="0"/>
+              <a:rPr lang="en-GB" dirty="0"/>
               <a:t>Multi-LLM Collaboration or Agentic Pipelines</a:t>
             </a:r>
           </a:p>
@@ -8346,10 +8362,10 @@
               <a:buChar char="●"/>
             </a:pPr>
             <a:r>
-              <a:rPr lang="en-GB" sz="1500" dirty="0"/>
+              <a:rPr lang="en-GB" dirty="0"/>
               <a:t>Complex CV event detection with high accuracy VLMs</a:t>
             </a:r>
-            <a:endParaRPr sz="1500" dirty="0"/>
+            <a:endParaRPr dirty="0"/>
           </a:p>
           <a:p>
             <a:pPr marL="457200" lvl="0" indent="-342900" algn="l" rtl="0">
@@ -8366,10 +8382,10 @@
               <a:buChar char="●"/>
             </a:pPr>
             <a:r>
-              <a:rPr lang="en-GB" sz="1500" dirty="0"/>
+              <a:rPr lang="en-GB" dirty="0"/>
               <a:t>Enhanced Log Semantics and Event Ontologies</a:t>
             </a:r>
-            <a:endParaRPr sz="1500" dirty="0"/>
+            <a:endParaRPr dirty="0"/>
           </a:p>
           <a:p>
             <a:pPr marL="457200" lvl="0" indent="-342900" algn="l" rtl="0">
@@ -8386,10 +8402,10 @@
               <a:buChar char="●"/>
             </a:pPr>
             <a:r>
-              <a:rPr lang="en-GB" sz="1500" dirty="0"/>
+              <a:rPr lang="en-GB" dirty="0"/>
               <a:t>Human-in-the-Loop Feedback for Continual Learning</a:t>
             </a:r>
-            <a:endParaRPr sz="1500" dirty="0"/>
+            <a:endParaRPr dirty="0"/>
           </a:p>
           <a:p>
             <a:pPr marL="457200" lvl="0" indent="-342900" algn="l" rtl="0">
@@ -8406,10 +8422,10 @@
               <a:buChar char="●"/>
             </a:pPr>
             <a:r>
-              <a:rPr lang="en-GB" sz="1500" dirty="0"/>
+              <a:rPr lang="en-GB" dirty="0"/>
               <a:t>Contextual Multi-Modal Reasoning</a:t>
             </a:r>
-            <a:endParaRPr sz="1500" dirty="0"/>
+            <a:endParaRPr dirty="0"/>
           </a:p>
         </p:txBody>
       </p:sp>
@@ -8421,7 +8437,7 @@
 </p:sld>
 </file>
 
-<file path=ppt/slides/slide16.xml><?xml version="1.0" encoding="utf-8"?>
+<file path=ppt/slides/slide17.xml><?xml version="1.0" encoding="utf-8"?>
 <p:sld xmlns:a="http://schemas.openxmlformats.org/drawingml/2006/main" xmlns:r="http://schemas.openxmlformats.org/officeDocument/2006/relationships" xmlns:p="http://schemas.openxmlformats.org/presentationml/2006/main">
   <p:cSld>
     <p:spTree>
@@ -8476,10 +8492,10 @@
               <a:buNone/>
             </a:pPr>
             <a:r>
-              <a:rPr lang="en-GB" dirty="0"/>
+              <a:rPr lang="en-GB" sz="3100" b="1" dirty="0"/>
               <a:t>Progress</a:t>
             </a:r>
-            <a:endParaRPr dirty="0"/>
+            <a:endParaRPr sz="3100" b="1" dirty="0"/>
           </a:p>
           <a:p>
             <a:pPr marL="457200" lvl="0" indent="-291465" algn="l" rtl="0">
@@ -8543,7 +8559,7 @@
               <a:buNone/>
             </a:pPr>
             <a:r>
-              <a:rPr lang="en-IN" sz="1500" b="1" dirty="0"/>
+              <a:rPr lang="en-IN" b="1" dirty="0"/>
               <a:t>Previous Review (Completed)</a:t>
             </a:r>
           </a:p>
@@ -8554,7 +8570,7 @@
               </a:lnSpc>
             </a:pPr>
             <a:r>
-              <a:rPr lang="en-IN" sz="1500" dirty="0"/>
+              <a:rPr lang="en-IN" dirty="0"/>
               <a:t>Concept finalized</a:t>
             </a:r>
           </a:p>
@@ -8565,7 +8581,7 @@
               </a:lnSpc>
             </a:pPr>
             <a:r>
-              <a:rPr lang="en-IN" sz="1500" dirty="0"/>
+              <a:rPr lang="en-IN" dirty="0"/>
               <a:t>Literature survey completed</a:t>
             </a:r>
           </a:p>
@@ -8576,7 +8592,7 @@
               </a:lnSpc>
             </a:pPr>
             <a:r>
-              <a:rPr lang="en-IN" sz="1500" dirty="0"/>
+              <a:rPr lang="en-IN" dirty="0"/>
               <a:t>System architecture designed</a:t>
             </a:r>
           </a:p>
@@ -8587,7 +8603,7 @@
               </a:lnSpc>
             </a:pPr>
             <a:r>
-              <a:rPr lang="en-IN" sz="1500" dirty="0"/>
+              <a:rPr lang="en-IN" dirty="0"/>
               <a:t>Feasibility validated for CV event detection </a:t>
             </a:r>
           </a:p>
@@ -8598,7 +8614,7 @@
               </a:lnSpc>
               <a:buNone/>
             </a:pPr>
-            <a:endParaRPr lang="en-IN" sz="1500" dirty="0"/>
+            <a:endParaRPr lang="en-IN" dirty="0"/>
           </a:p>
           <a:p>
             <a:pPr marL="114300" indent="0">
@@ -8607,7 +8623,7 @@
               </a:lnSpc>
               <a:buNone/>
             </a:pPr>
-            <a:endParaRPr lang="en-IN" sz="1500" dirty="0"/>
+            <a:endParaRPr lang="en-IN" dirty="0"/>
           </a:p>
         </p:txBody>
       </p:sp>
@@ -8721,7 +8737,7 @@
 </p:sld>
 </file>
 
-<file path=ppt/slides/slide17.xml><?xml version="1.0" encoding="utf-8"?>
+<file path=ppt/slides/slide18.xml><?xml version="1.0" encoding="utf-8"?>
 <p:sld xmlns:a="http://schemas.openxmlformats.org/drawingml/2006/main" xmlns:r="http://schemas.openxmlformats.org/officeDocument/2006/relationships" xmlns:p="http://schemas.openxmlformats.org/presentationml/2006/main">
   <p:cSld>
     <p:spTree>
@@ -8757,15 +8773,15 @@
         <p:spPr/>
         <p:txBody>
           <a:bodyPr>
-            <a:normAutofit fontScale="90000"/>
+            <a:noAutofit/>
           </a:bodyPr>
           <a:lstStyle/>
           <a:p>
             <a:r>
-              <a:rPr lang="en-GB" dirty="0"/>
+              <a:rPr lang="en-GB" b="1" dirty="0"/>
               <a:t>Progress</a:t>
             </a:r>
-            <a:endParaRPr lang="en-IN" dirty="0"/>
+            <a:endParaRPr lang="en-IN" b="1" dirty="0"/>
           </a:p>
         </p:txBody>
       </p:sp>
@@ -8788,7 +8804,7 @@
         <p:spPr/>
         <p:txBody>
           <a:bodyPr>
-            <a:normAutofit fontScale="92500" lnSpcReduction="10000"/>
+            <a:noAutofit/>
           </a:bodyPr>
           <a:lstStyle/>
           <a:p>
@@ -8799,7 +8815,7 @@
               <a:buNone/>
             </a:pPr>
             <a:r>
-              <a:rPr lang="en-IN" sz="1500" b="1" dirty="0"/>
+              <a:rPr lang="en-IN" b="1" dirty="0"/>
               <a:t>Current Final Review (This Semester)</a:t>
             </a:r>
           </a:p>
@@ -8810,15 +8826,15 @@
               </a:lnSpc>
             </a:pPr>
             <a:r>
-              <a:rPr lang="en-IN" sz="1500" dirty="0"/>
+              <a:rPr lang="en-IN" sz="1600" dirty="0"/>
               <a:t>Implemented </a:t>
             </a:r>
             <a:r>
-              <a:rPr lang="en-IN" sz="1500" b="1" dirty="0"/>
+              <a:rPr lang="en-IN" sz="1600" b="1" dirty="0"/>
               <a:t>4 CV event detectors</a:t>
             </a:r>
             <a:r>
-              <a:rPr lang="en-IN" sz="1500" dirty="0"/>
+              <a:rPr lang="en-IN" sz="1600" dirty="0"/>
               <a:t>:</a:t>
             </a:r>
           </a:p>
@@ -8829,7 +8845,7 @@
               </a:lnSpc>
             </a:pPr>
             <a:r>
-              <a:rPr lang="en-IN" sz="1500" dirty="0"/>
+              <a:rPr lang="en-IN" sz="1600" dirty="0"/>
               <a:t>Person entry/exit</a:t>
             </a:r>
           </a:p>
@@ -8840,7 +8856,7 @@
               </a:lnSpc>
             </a:pPr>
             <a:r>
-              <a:rPr lang="en-IN" sz="1500" dirty="0"/>
+              <a:rPr lang="en-IN" sz="1600" dirty="0"/>
               <a:t>Vehicle entry/exit</a:t>
             </a:r>
           </a:p>
@@ -8851,7 +8867,7 @@
               </a:lnSpc>
             </a:pPr>
             <a:r>
-              <a:rPr lang="en-IN" sz="1500" dirty="0"/>
+              <a:rPr lang="en-IN" sz="1600" dirty="0"/>
               <a:t>Crowd formation/density</a:t>
             </a:r>
           </a:p>
@@ -8862,7 +8878,7 @@
               </a:lnSpc>
             </a:pPr>
             <a:r>
-              <a:rPr lang="en-IN" sz="1500" dirty="0"/>
+              <a:rPr lang="en-IN" sz="1600" dirty="0"/>
               <a:t>Abandoned object detection</a:t>
             </a:r>
           </a:p>
@@ -8873,14 +8889,14 @@
               </a:lnSpc>
             </a:pPr>
             <a:r>
-              <a:rPr lang="en-IN" sz="1500" dirty="0"/>
+              <a:rPr lang="en-IN" sz="1600" dirty="0"/>
               <a:t>Built </a:t>
             </a:r>
             <a:r>
-              <a:rPr lang="en-IN" sz="1500" b="1" dirty="0"/>
+              <a:rPr lang="en-IN" sz="1600" b="1" dirty="0"/>
               <a:t>real-time JSON log generator</a:t>
             </a:r>
-            <a:endParaRPr lang="en-IN" sz="1500" dirty="0"/>
+            <a:endParaRPr lang="en-IN" sz="1600" dirty="0"/>
           </a:p>
           <a:p>
             <a:pPr>
@@ -8889,15 +8905,15 @@
               </a:lnSpc>
             </a:pPr>
             <a:r>
-              <a:rPr lang="en-IN" sz="1500" dirty="0"/>
+              <a:rPr lang="en-IN" sz="1600" dirty="0"/>
               <a:t>Implemented </a:t>
             </a:r>
             <a:r>
-              <a:rPr lang="en-IN" sz="1500" b="1" dirty="0"/>
+              <a:rPr lang="en-IN" sz="1600" b="1" dirty="0"/>
               <a:t>LLM Query Engine</a:t>
             </a:r>
             <a:r>
-              <a:rPr lang="en-IN" sz="1500" dirty="0"/>
+              <a:rPr lang="en-IN" sz="1600" dirty="0"/>
               <a:t> (Zero-Shot reasoning + RAG retrieval)</a:t>
             </a:r>
           </a:p>
@@ -8908,15 +8924,15 @@
               </a:lnSpc>
             </a:pPr>
             <a:r>
-              <a:rPr lang="en-IN" sz="1500" dirty="0"/>
+              <a:rPr lang="en-IN" sz="1600" dirty="0"/>
               <a:t>Achieved </a:t>
             </a:r>
             <a:r>
-              <a:rPr lang="en-IN" sz="1500" b="1" dirty="0"/>
+              <a:rPr lang="en-IN" sz="1600" b="1" dirty="0"/>
               <a:t>end-to-end working prototype</a:t>
             </a:r>
             <a:r>
-              <a:rPr lang="en-IN" sz="1500" dirty="0"/>
+              <a:rPr lang="en-IN" sz="1600" dirty="0"/>
               <a:t>: CV → Logs → LLM analytics</a:t>
             </a:r>
           </a:p>
@@ -8941,7 +8957,7 @@
 </p:sld>
 </file>
 
-<file path=ppt/slides/slide18.xml><?xml version="1.0" encoding="utf-8"?>
+<file path=ppt/slides/slide19.xml><?xml version="1.0" encoding="utf-8"?>
 <p:sld xmlns:a="http://schemas.openxmlformats.org/drawingml/2006/main" xmlns:r="http://schemas.openxmlformats.org/officeDocument/2006/relationships" xmlns:p="http://schemas.openxmlformats.org/presentationml/2006/main">
   <p:cSld>
     <p:spTree>
@@ -8996,7 +9012,7 @@
               <a:buNone/>
             </a:pPr>
             <a:r>
-              <a:rPr lang="en-IN" sz="1500" b="1" dirty="0"/>
+              <a:rPr lang="en-IN" b="1" dirty="0"/>
               <a:t>Next Semester Plan</a:t>
             </a:r>
           </a:p>
@@ -9007,7 +9023,7 @@
               </a:lnSpc>
               <a:buNone/>
             </a:pPr>
-            <a:endParaRPr lang="en-IN" sz="1500" dirty="0"/>
+            <a:endParaRPr lang="en-IN" dirty="0"/>
           </a:p>
           <a:p>
             <a:pPr>
@@ -9016,15 +9032,15 @@
               </a:lnSpc>
             </a:pPr>
             <a:r>
-              <a:rPr lang="en-IN" sz="1500" dirty="0"/>
+              <a:rPr lang="en-IN" dirty="0"/>
               <a:t>Build </a:t>
             </a:r>
             <a:r>
-              <a:rPr lang="en-IN" sz="1500" b="1" dirty="0"/>
+              <a:rPr lang="en-IN" b="1" dirty="0"/>
               <a:t>Custom CCTV Dataset</a:t>
             </a:r>
             <a:r>
-              <a:rPr lang="en-IN" sz="1500" dirty="0"/>
+              <a:rPr lang="en-IN" dirty="0"/>
               <a:t> (University CCTV footage covering all event types)</a:t>
             </a:r>
           </a:p>
@@ -9035,15 +9051,15 @@
               </a:lnSpc>
             </a:pPr>
             <a:r>
-              <a:rPr lang="en-IN" sz="1500" dirty="0"/>
+              <a:rPr lang="en-IN" dirty="0"/>
               <a:t>Create </a:t>
             </a:r>
             <a:r>
-              <a:rPr lang="en-IN" sz="1500" b="1" dirty="0"/>
+              <a:rPr lang="en-IN" b="1" dirty="0"/>
               <a:t>Novel Structured Log Dataset</a:t>
             </a:r>
             <a:r>
-              <a:rPr lang="en-IN" sz="1500" dirty="0"/>
+              <a:rPr lang="en-IN" dirty="0"/>
               <a:t> for LLM training</a:t>
             </a:r>
           </a:p>
@@ -9054,15 +9070,15 @@
               </a:lnSpc>
             </a:pPr>
             <a:r>
-              <a:rPr lang="en-IN" sz="1500" dirty="0"/>
+              <a:rPr lang="en-IN" dirty="0"/>
               <a:t>Complete </a:t>
             </a:r>
             <a:r>
-              <a:rPr lang="en-IN" sz="1500" b="1" dirty="0"/>
+              <a:rPr lang="en-IN" b="1" dirty="0"/>
               <a:t>LLM Research Components</a:t>
             </a:r>
             <a:r>
-              <a:rPr lang="en-IN" sz="1500" dirty="0"/>
+              <a:rPr lang="en-IN" dirty="0"/>
               <a:t>:</a:t>
             </a:r>
           </a:p>
@@ -9073,7 +9089,7 @@
               </a:lnSpc>
             </a:pPr>
             <a:r>
-              <a:rPr lang="en-IN" sz="1500" dirty="0"/>
+              <a:rPr lang="en-IN" sz="1600" dirty="0"/>
               <a:t>Query translation (NL → filters/SQL/logic)</a:t>
             </a:r>
           </a:p>
@@ -9084,7 +9100,7 @@
               </a:lnSpc>
             </a:pPr>
             <a:r>
-              <a:rPr lang="en-IN" sz="1500" dirty="0"/>
+              <a:rPr lang="en-IN" sz="1600" dirty="0"/>
               <a:t>Temporal &amp; spatial incident summarization</a:t>
             </a:r>
           </a:p>
@@ -9095,18 +9111,18 @@
               </a:lnSpc>
             </a:pPr>
             <a:r>
-              <a:rPr lang="en-IN" sz="1500" dirty="0"/>
+              <a:rPr lang="en-IN" dirty="0"/>
               <a:t>Deliver </a:t>
             </a:r>
             <a:r>
-              <a:rPr lang="en-IN" sz="1500" b="1" dirty="0"/>
+              <a:rPr lang="en-IN" b="1" dirty="0"/>
               <a:t>Final Integrated System</a:t>
             </a:r>
             <a:r>
-              <a:rPr lang="en-IN" sz="1500" dirty="0"/>
+              <a:rPr lang="en-IN" dirty="0"/>
               <a:t> + thesis completion</a:t>
             </a:r>
-            <a:endParaRPr lang="en-IN" sz="1500" dirty="0">
+            <a:endParaRPr lang="en-IN" dirty="0">
               <a:effectLst/>
             </a:endParaRPr>
           </a:p>
@@ -9136,15 +9152,15 @@
         </p:spPr>
         <p:txBody>
           <a:bodyPr>
-            <a:normAutofit fontScale="90000"/>
+            <a:noAutofit/>
           </a:bodyPr>
           <a:lstStyle/>
           <a:p>
             <a:r>
-              <a:rPr lang="en-GB" dirty="0"/>
+              <a:rPr lang="en-GB" b="1" dirty="0"/>
               <a:t>Progress</a:t>
             </a:r>
-            <a:endParaRPr lang="en-IN" dirty="0"/>
+            <a:endParaRPr lang="en-IN" b="1" dirty="0"/>
           </a:p>
         </p:txBody>
       </p:sp>
@@ -9154,392 +9170,6 @@
         <p14:creationId xmlns:p14="http://schemas.microsoft.com/office/powerpoint/2010/main" val="128542769"/>
       </p:ext>
     </p:extLst>
-  </p:cSld>
-  <p:clrMapOvr>
-    <a:masterClrMapping/>
-  </p:clrMapOvr>
-</p:sld>
-</file>
-
-<file path=ppt/slides/slide19.xml><?xml version="1.0" encoding="utf-8"?>
-<p:sld xmlns:a="http://schemas.openxmlformats.org/drawingml/2006/main" xmlns:r="http://schemas.openxmlformats.org/officeDocument/2006/relationships" xmlns:p="http://schemas.openxmlformats.org/presentationml/2006/main">
-  <p:cSld>
-    <p:spTree>
-      <p:nvGrpSpPr>
-        <p:cNvPr id="1" name="Shape 120"/>
-        <p:cNvGrpSpPr/>
-        <p:nvPr/>
-      </p:nvGrpSpPr>
-      <p:grpSpPr>
-        <a:xfrm>
-          <a:off x="0" y="0"/>
-          <a:ext cx="0" cy="0"/>
-          <a:chOff x="0" y="0"/>
-          <a:chExt cx="0" cy="0"/>
-        </a:xfrm>
-      </p:grpSpPr>
-      <p:sp>
-        <p:nvSpPr>
-          <p:cNvPr id="121" name="Google Shape;121;p24"/>
-          <p:cNvSpPr txBox="1">
-            <a:spLocks noGrp="1"/>
-          </p:cNvSpPr>
-          <p:nvPr>
-            <p:ph type="title"/>
-          </p:nvPr>
-        </p:nvSpPr>
-        <p:spPr>
-          <a:xfrm>
-            <a:off x="311700" y="445025"/>
-            <a:ext cx="8520600" cy="572700"/>
-          </a:xfrm>
-          <a:prstGeom prst="rect">
-            <a:avLst/>
-          </a:prstGeom>
-        </p:spPr>
-        <p:txBody>
-          <a:bodyPr spcFirstLastPara="1" wrap="square" lIns="91425" tIns="91425" rIns="91425" bIns="91425" anchor="t" anchorCtr="0">
-            <a:normAutofit fontScale="90000"/>
-          </a:bodyPr>
-          <a:lstStyle/>
-          <a:p>
-            <a:pPr marL="0" lvl="0" indent="0" algn="l" rtl="0">
-              <a:lnSpc>
-                <a:spcPct val="115000"/>
-              </a:lnSpc>
-              <a:spcBef>
-                <a:spcPts val="1200"/>
-              </a:spcBef>
-              <a:spcAft>
-                <a:spcPts val="0"/>
-              </a:spcAft>
-              <a:buNone/>
-            </a:pPr>
-            <a:r>
-              <a:rPr lang="en-GB" dirty="0"/>
-              <a:t>References</a:t>
-            </a:r>
-            <a:endParaRPr dirty="0"/>
-          </a:p>
-          <a:p>
-            <a:pPr marL="457200" lvl="0" indent="-291465" algn="l" rtl="0">
-              <a:lnSpc>
-                <a:spcPct val="115000"/>
-              </a:lnSpc>
-              <a:spcBef>
-                <a:spcPts val="1200"/>
-              </a:spcBef>
-              <a:spcAft>
-                <a:spcPts val="0"/>
-              </a:spcAft>
-              <a:buSzPct val="39285"/>
-              <a:buChar char="●"/>
-            </a:pPr>
-            <a:endParaRPr dirty="0"/>
-          </a:p>
-          <a:p>
-            <a:pPr marL="0" lvl="0" indent="0" algn="l" rtl="0">
-              <a:spcBef>
-                <a:spcPts val="1200"/>
-              </a:spcBef>
-              <a:spcAft>
-                <a:spcPts val="0"/>
-              </a:spcAft>
-              <a:buNone/>
-            </a:pPr>
-            <a:endParaRPr dirty="0"/>
-          </a:p>
-        </p:txBody>
-      </p:sp>
-      <p:sp>
-        <p:nvSpPr>
-          <p:cNvPr id="122" name="Google Shape;122;p24"/>
-          <p:cNvSpPr txBox="1">
-            <a:spLocks noGrp="1"/>
-          </p:cNvSpPr>
-          <p:nvPr>
-            <p:ph type="body" idx="1"/>
-          </p:nvPr>
-        </p:nvSpPr>
-        <p:spPr>
-          <a:xfrm>
-            <a:off x="311700" y="1152475"/>
-            <a:ext cx="8520600" cy="3416400"/>
-          </a:xfrm>
-          <a:prstGeom prst="rect">
-            <a:avLst/>
-          </a:prstGeom>
-        </p:spPr>
-        <p:txBody>
-          <a:bodyPr spcFirstLastPara="1" wrap="square" lIns="91425" tIns="91425" rIns="91425" bIns="91425" anchor="t" anchorCtr="0">
-            <a:noAutofit/>
-          </a:bodyPr>
-          <a:lstStyle/>
-          <a:p>
-            <a:pPr marL="0" lvl="0" indent="0">
-              <a:spcAft>
-                <a:spcPts val="1200"/>
-              </a:spcAft>
-              <a:buNone/>
-            </a:pPr>
-            <a:r>
-              <a:rPr lang="en-IN" sz="1000" dirty="0">
-                <a:hlinkClick r:id="rId3" action="ppaction://hlinksldjump"/>
-              </a:rPr>
-              <a:t>[1]</a:t>
-            </a:r>
-            <a:r>
-              <a:rPr lang="en-IN" sz="1000" dirty="0"/>
-              <a:t> U. De Silva, L. Fernando, B. Lau Pik Lik, Z. Koh, S. C. Joyce, B. Yuen, </a:t>
-            </a:r>
-            <a:r>
-              <a:rPr lang="en-IN" sz="1000" dirty="0" err="1"/>
-              <a:t>andC</a:t>
-            </a:r>
-            <a:r>
-              <a:rPr lang="en-IN" sz="1000" dirty="0"/>
-              <a:t>. Yuen, “Large language models for video surveillance applications,” </a:t>
-            </a:r>
-            <a:r>
-              <a:rPr lang="en-IN" sz="1000" dirty="0" err="1"/>
-              <a:t>arXiv</a:t>
-            </a:r>
-            <a:r>
-              <a:rPr lang="en-IN" sz="1000" dirty="0"/>
-              <a:t> preprintarXiv:2501.02850, 2025.</a:t>
-            </a:r>
-          </a:p>
-          <a:p>
-            <a:pPr marL="0" lvl="0" indent="0">
-              <a:spcAft>
-                <a:spcPts val="1200"/>
-              </a:spcAft>
-              <a:buNone/>
-            </a:pPr>
-            <a:r>
-              <a:rPr lang="en-IN" sz="1000" dirty="0">
-                <a:hlinkClick r:id="rId4" action="ppaction://hlinksldjump"/>
-              </a:rPr>
-              <a:t>[2]</a:t>
-            </a:r>
-            <a:r>
-              <a:rPr lang="en-IN" sz="1000" dirty="0"/>
-              <a:t> C.-Y. Wang, A. </a:t>
-            </a:r>
-            <a:r>
-              <a:rPr lang="en-IN" sz="1000" dirty="0" err="1"/>
-              <a:t>Bochkovskiy</a:t>
-            </a:r>
-            <a:r>
-              <a:rPr lang="en-IN" sz="1000" dirty="0"/>
-              <a:t>, and H.-Y. M. Liao, “Yolov7: Trainable bag-of-freebies sets new state-of-the-art for real-time object detectors,” </a:t>
-            </a:r>
-            <a:r>
-              <a:rPr lang="en-IN" sz="1000" dirty="0" err="1"/>
-              <a:t>arXiv</a:t>
-            </a:r>
-            <a:r>
-              <a:rPr lang="en-IN" sz="1000" dirty="0"/>
-              <a:t> preprintarXiv:2207.02696, 2022.</a:t>
-            </a:r>
-          </a:p>
-          <a:p>
-            <a:pPr marL="0" lvl="0" indent="0">
-              <a:spcAft>
-                <a:spcPts val="1200"/>
-              </a:spcAft>
-              <a:buNone/>
-            </a:pPr>
-            <a:r>
-              <a:rPr lang="en-IN" sz="1000" dirty="0">
-                <a:hlinkClick r:id="rId4" action="ppaction://hlinksldjump"/>
-              </a:rPr>
-              <a:t>[3]</a:t>
-            </a:r>
-            <a:r>
-              <a:rPr lang="en-IN" sz="1000" dirty="0"/>
-              <a:t> M. Yaseen, “What is yolov8: An in-depth exploration of the internal features of </a:t>
-            </a:r>
-            <a:r>
-              <a:rPr lang="en-IN" sz="1000" dirty="0" err="1"/>
-              <a:t>thenext</a:t>
-            </a:r>
-            <a:r>
-              <a:rPr lang="en-IN" sz="1000" dirty="0"/>
-              <a:t>-generation object detector,” </a:t>
-            </a:r>
-            <a:r>
-              <a:rPr lang="en-IN" sz="1000" dirty="0" err="1"/>
-              <a:t>arXiv</a:t>
-            </a:r>
-            <a:r>
-              <a:rPr lang="en-IN" sz="1000" dirty="0"/>
-              <a:t> preprint arXiv:2408.15857, 2024.</a:t>
-            </a:r>
-          </a:p>
-          <a:p>
-            <a:pPr marL="0" lvl="0" indent="0">
-              <a:spcAft>
-                <a:spcPts val="1200"/>
-              </a:spcAft>
-              <a:buNone/>
-            </a:pPr>
-            <a:r>
-              <a:rPr lang="en-IN" sz="1000" dirty="0">
-                <a:hlinkClick r:id="rId4" action="ppaction://hlinksldjump"/>
-              </a:rPr>
-              <a:t>[4]</a:t>
-            </a:r>
-            <a:r>
-              <a:rPr lang="en-IN" sz="1000" dirty="0"/>
-              <a:t> D. </a:t>
-            </a:r>
-            <a:r>
-              <a:rPr lang="en-IN" sz="1000" dirty="0" err="1"/>
-              <a:t>Gragnaniello</a:t>
-            </a:r>
-            <a:r>
-              <a:rPr lang="en-IN" sz="1000" dirty="0"/>
-              <a:t>, A. Greco, C. Sansone, and B. Vento, “FLAME: fire detection </a:t>
-            </a:r>
-            <a:r>
-              <a:rPr lang="en-IN" sz="1000" dirty="0" err="1"/>
-              <a:t>invideos</a:t>
-            </a:r>
-            <a:r>
-              <a:rPr lang="en-IN" sz="1000" dirty="0"/>
-              <a:t> combining a deep neural network with a model-based motion analysis,” </a:t>
-            </a:r>
-            <a:r>
-              <a:rPr lang="en-IN" sz="1000" dirty="0" err="1"/>
-              <a:t>NeuralComputing</a:t>
-            </a:r>
-            <a:r>
-              <a:rPr lang="en-IN" sz="1000" dirty="0"/>
-              <a:t> and Applications, vol. 37, pp. 6181–6197, 2025.</a:t>
-            </a:r>
-          </a:p>
-          <a:p>
-            <a:pPr marL="0" lvl="0" indent="0">
-              <a:spcAft>
-                <a:spcPts val="1200"/>
-              </a:spcAft>
-              <a:buNone/>
-            </a:pPr>
-            <a:r>
-              <a:rPr lang="en-IN" sz="1000" dirty="0">
-                <a:hlinkClick r:id="rId4" action="ppaction://hlinksldjump"/>
-              </a:rPr>
-              <a:t>[5]</a:t>
-            </a:r>
-            <a:r>
-              <a:rPr lang="en-IN" sz="1000" dirty="0"/>
-              <a:t> A. </a:t>
-            </a:r>
-            <a:r>
-              <a:rPr lang="en-IN" sz="1000" dirty="0" err="1"/>
-              <a:t>Joemon</a:t>
-            </a:r>
-            <a:r>
-              <a:rPr lang="en-IN" sz="1000" dirty="0"/>
-              <a:t>, A. C. Joy, A. V. Prakash, B. Thomas, and D. R, “Abnormal event </a:t>
-            </a:r>
-            <a:r>
-              <a:rPr lang="en-IN" sz="1000" dirty="0" err="1"/>
-              <a:t>detec-tion</a:t>
-            </a:r>
-            <a:r>
-              <a:rPr lang="en-IN" sz="1000" dirty="0"/>
-              <a:t> using </a:t>
-            </a:r>
-            <a:r>
-              <a:rPr lang="en-IN" sz="1000" dirty="0" err="1"/>
-              <a:t>cctv</a:t>
-            </a:r>
-            <a:r>
-              <a:rPr lang="en-IN" sz="1000" dirty="0"/>
-              <a:t> camera,” International Journal of Innovative Science and </a:t>
-            </a:r>
-            <a:r>
-              <a:rPr lang="en-IN" sz="1000" dirty="0" err="1"/>
-              <a:t>ResearchTechnology</a:t>
-            </a:r>
-            <a:r>
-              <a:rPr lang="en-IN" sz="1000" dirty="0"/>
-              <a:t> (IJISRT), vol. 6, no. 6, pp. 608–612, 2021.</a:t>
-            </a:r>
-          </a:p>
-          <a:p>
-            <a:pPr marL="0" lvl="0" indent="0">
-              <a:spcAft>
-                <a:spcPts val="1200"/>
-              </a:spcAft>
-              <a:buNone/>
-            </a:pPr>
-            <a:r>
-              <a:rPr lang="en-IN" sz="1000" dirty="0">
-                <a:hlinkClick r:id="rId3" action="ppaction://hlinksldjump"/>
-              </a:rPr>
-              <a:t>[6]</a:t>
-            </a:r>
-            <a:r>
-              <a:rPr lang="en-IN" sz="1000" dirty="0"/>
-              <a:t> M. Wang, Y. Zhang, Q. Zhao, J. Yang, and H. Zhang, “Redefining </a:t>
-            </a:r>
-            <a:r>
-              <a:rPr lang="en-IN" sz="1000" dirty="0" err="1"/>
-              <a:t>informa-tion</a:t>
-            </a:r>
-            <a:r>
-              <a:rPr lang="en-IN" sz="1000" dirty="0"/>
-              <a:t> retrieval of structured database via large language models,” </a:t>
-            </a:r>
-            <a:r>
-              <a:rPr lang="en-IN" sz="1000" dirty="0" err="1"/>
-              <a:t>arXiv</a:t>
-            </a:r>
-            <a:r>
-              <a:rPr lang="en-IN" sz="1000" dirty="0"/>
-              <a:t> preprintarXiv:2405.05508, 2024.</a:t>
-            </a:r>
-          </a:p>
-          <a:p>
-            <a:pPr marL="0" lvl="0" indent="0">
-              <a:spcAft>
-                <a:spcPts val="1200"/>
-              </a:spcAft>
-              <a:buNone/>
-            </a:pPr>
-            <a:r>
-              <a:rPr lang="en-IN" sz="1000" dirty="0">
-                <a:hlinkClick r:id="rId3" action="ppaction://hlinksldjump"/>
-              </a:rPr>
-              <a:t>[7]</a:t>
-            </a:r>
-            <a:r>
-              <a:rPr lang="en-IN" sz="1000" dirty="0"/>
-              <a:t> J. Myung, J. Park, S. Park, K. Lee, H. Kim, and S. Lee, “Hyst: </a:t>
-            </a:r>
-            <a:r>
-              <a:rPr lang="en-IN" sz="1000" dirty="0" err="1"/>
-              <a:t>Llm-poweredhybrid</a:t>
-            </a:r>
-            <a:r>
-              <a:rPr lang="en-IN" sz="1000" dirty="0"/>
-              <a:t> retrieval over semi-structured tabular data,” in Proceedings of the 2nd </a:t>
-            </a:r>
-            <a:r>
-              <a:rPr lang="en-IN" sz="1000" dirty="0" err="1"/>
-              <a:t>EARLWorkshop</a:t>
-            </a:r>
-            <a:r>
-              <a:rPr lang="en-IN" sz="1000" dirty="0"/>
-              <a:t> on Evaluating and Applying Recommender Systems with LLMs, 2025.16</a:t>
-            </a:r>
-          </a:p>
-        </p:txBody>
-      </p:sp>
-    </p:spTree>
   </p:cSld>
   <p:clrMapOvr>
     <a:masterClrMapping/>
@@ -9585,7 +9215,7 @@
         </p:spPr>
         <p:txBody>
           <a:bodyPr spcFirstLastPara="1" wrap="square" lIns="91425" tIns="91425" rIns="91425" bIns="91425" anchor="t" anchorCtr="0">
-            <a:normAutofit fontScale="90000"/>
+            <a:noAutofit/>
           </a:bodyPr>
           <a:lstStyle/>
           <a:p>
@@ -9599,10 +9229,10 @@
               <a:buNone/>
             </a:pPr>
             <a:r>
-              <a:rPr lang="en-GB"/>
-              <a:t>Problem Defination</a:t>
-            </a:r>
-            <a:endParaRPr/>
+              <a:rPr lang="en-GB" b="1" dirty="0"/>
+              <a:t>Problem Definition</a:t>
+            </a:r>
+            <a:endParaRPr b="1" dirty="0"/>
           </a:p>
         </p:txBody>
       </p:sp>
@@ -9645,10 +9275,10 @@
               <a:buChar char="●"/>
             </a:pPr>
             <a:r>
-              <a:rPr lang="en-GB" sz="1500" dirty="0"/>
+              <a:rPr lang="en-GB" dirty="0"/>
               <a:t>Surveillance cameras produce massive video streams</a:t>
             </a:r>
-            <a:endParaRPr sz="1500" dirty="0"/>
+            <a:endParaRPr dirty="0"/>
           </a:p>
           <a:p>
             <a:pPr marL="457200" lvl="0" indent="-342900" algn="l" rtl="0">
@@ -9665,18 +9295,10 @@
               <a:buChar char="●"/>
             </a:pPr>
             <a:r>
-              <a:rPr lang="en-GB" sz="1500" dirty="0"/>
-              <a:t>Manual review is slow, </a:t>
-            </a:r>
-            <a:r>
-              <a:rPr lang="en-GB" sz="1500" dirty="0" err="1"/>
-              <a:t>labor-intensive</a:t>
-            </a:r>
-            <a:r>
-              <a:rPr lang="en-GB" sz="1500" dirty="0"/>
-              <a:t>, and prone to oversight.</a:t>
-            </a:r>
-            <a:endParaRPr sz="1500" dirty="0"/>
+              <a:rPr lang="en-GB" dirty="0"/>
+              <a:t>Manual review is slow, labour-intensive, and prone to oversight.</a:t>
+            </a:r>
+            <a:endParaRPr dirty="0"/>
           </a:p>
           <a:p>
             <a:pPr marL="457200" lvl="0" indent="-342900" algn="l" rtl="0">
@@ -9693,10 +9315,10 @@
               <a:buChar char="●"/>
             </a:pPr>
             <a:r>
-              <a:rPr lang="en-GB" sz="1500" dirty="0"/>
+              <a:rPr lang="en-GB" dirty="0"/>
               <a:t>Existing systems focus on low-level detection/tracking and rely on human interpretation, lacking deeper situational understanding and actionable insights.</a:t>
             </a:r>
-            <a:endParaRPr sz="1500" dirty="0"/>
+            <a:endParaRPr dirty="0"/>
           </a:p>
         </p:txBody>
       </p:sp>
@@ -9709,6 +9331,392 @@
 </file>
 
 <file path=ppt/slides/slide20.xml><?xml version="1.0" encoding="utf-8"?>
+<p:sld xmlns:a="http://schemas.openxmlformats.org/drawingml/2006/main" xmlns:r="http://schemas.openxmlformats.org/officeDocument/2006/relationships" xmlns:p="http://schemas.openxmlformats.org/presentationml/2006/main">
+  <p:cSld>
+    <p:spTree>
+      <p:nvGrpSpPr>
+        <p:cNvPr id="1" name="Shape 120"/>
+        <p:cNvGrpSpPr/>
+        <p:nvPr/>
+      </p:nvGrpSpPr>
+      <p:grpSpPr>
+        <a:xfrm>
+          <a:off x="0" y="0"/>
+          <a:ext cx="0" cy="0"/>
+          <a:chOff x="0" y="0"/>
+          <a:chExt cx="0" cy="0"/>
+        </a:xfrm>
+      </p:grpSpPr>
+      <p:sp>
+        <p:nvSpPr>
+          <p:cNvPr id="121" name="Google Shape;121;p24"/>
+          <p:cNvSpPr txBox="1">
+            <a:spLocks noGrp="1"/>
+          </p:cNvSpPr>
+          <p:nvPr>
+            <p:ph type="title"/>
+          </p:nvPr>
+        </p:nvSpPr>
+        <p:spPr>
+          <a:xfrm>
+            <a:off x="311700" y="445025"/>
+            <a:ext cx="8520600" cy="572700"/>
+          </a:xfrm>
+          <a:prstGeom prst="rect">
+            <a:avLst/>
+          </a:prstGeom>
+        </p:spPr>
+        <p:txBody>
+          <a:bodyPr spcFirstLastPara="1" wrap="square" lIns="91425" tIns="91425" rIns="91425" bIns="91425" anchor="t" anchorCtr="0">
+            <a:normAutofit fontScale="90000"/>
+          </a:bodyPr>
+          <a:lstStyle/>
+          <a:p>
+            <a:pPr marL="0" lvl="0" indent="0" algn="l" rtl="0">
+              <a:lnSpc>
+                <a:spcPct val="115000"/>
+              </a:lnSpc>
+              <a:spcBef>
+                <a:spcPts val="1200"/>
+              </a:spcBef>
+              <a:spcAft>
+                <a:spcPts val="0"/>
+              </a:spcAft>
+              <a:buNone/>
+            </a:pPr>
+            <a:r>
+              <a:rPr lang="en-GB" sz="3100" b="1" dirty="0"/>
+              <a:t>References</a:t>
+            </a:r>
+            <a:endParaRPr sz="3100" b="1" dirty="0"/>
+          </a:p>
+          <a:p>
+            <a:pPr marL="457200" lvl="0" indent="-291465" algn="l" rtl="0">
+              <a:lnSpc>
+                <a:spcPct val="115000"/>
+              </a:lnSpc>
+              <a:spcBef>
+                <a:spcPts val="1200"/>
+              </a:spcBef>
+              <a:spcAft>
+                <a:spcPts val="0"/>
+              </a:spcAft>
+              <a:buSzPct val="39285"/>
+              <a:buChar char="●"/>
+            </a:pPr>
+            <a:endParaRPr dirty="0"/>
+          </a:p>
+          <a:p>
+            <a:pPr marL="0" lvl="0" indent="0" algn="l" rtl="0">
+              <a:spcBef>
+                <a:spcPts val="1200"/>
+              </a:spcBef>
+              <a:spcAft>
+                <a:spcPts val="0"/>
+              </a:spcAft>
+              <a:buNone/>
+            </a:pPr>
+            <a:endParaRPr dirty="0"/>
+          </a:p>
+        </p:txBody>
+      </p:sp>
+      <p:sp>
+        <p:nvSpPr>
+          <p:cNvPr id="122" name="Google Shape;122;p24"/>
+          <p:cNvSpPr txBox="1">
+            <a:spLocks noGrp="1"/>
+          </p:cNvSpPr>
+          <p:nvPr>
+            <p:ph type="body" idx="1"/>
+          </p:nvPr>
+        </p:nvSpPr>
+        <p:spPr>
+          <a:xfrm>
+            <a:off x="311700" y="1152475"/>
+            <a:ext cx="8520600" cy="3416400"/>
+          </a:xfrm>
+          <a:prstGeom prst="rect">
+            <a:avLst/>
+          </a:prstGeom>
+        </p:spPr>
+        <p:txBody>
+          <a:bodyPr spcFirstLastPara="1" wrap="square" lIns="91425" tIns="91425" rIns="91425" bIns="91425" anchor="t" anchorCtr="0">
+            <a:noAutofit/>
+          </a:bodyPr>
+          <a:lstStyle/>
+          <a:p>
+            <a:pPr marL="0" lvl="0" indent="0">
+              <a:spcAft>
+                <a:spcPts val="1200"/>
+              </a:spcAft>
+              <a:buNone/>
+            </a:pPr>
+            <a:r>
+              <a:rPr lang="en-IN" sz="1000" dirty="0">
+                <a:hlinkClick r:id="rId3" action="ppaction://hlinksldjump"/>
+              </a:rPr>
+              <a:t>[1]</a:t>
+            </a:r>
+            <a:r>
+              <a:rPr lang="en-IN" sz="1000" dirty="0"/>
+              <a:t> U. De Silva, L. Fernando, B. Lau Pik Lik, Z. Koh, S. C. Joyce, B. Yuen, </a:t>
+            </a:r>
+            <a:r>
+              <a:rPr lang="en-IN" sz="1000" dirty="0" err="1"/>
+              <a:t>andC</a:t>
+            </a:r>
+            <a:r>
+              <a:rPr lang="en-IN" sz="1000" dirty="0"/>
+              <a:t>. Yuen, “Large language models for video surveillance applications,” </a:t>
+            </a:r>
+            <a:r>
+              <a:rPr lang="en-IN" sz="1000" dirty="0" err="1"/>
+              <a:t>arXiv</a:t>
+            </a:r>
+            <a:r>
+              <a:rPr lang="en-IN" sz="1000" dirty="0"/>
+              <a:t> preprintarXiv:2501.02850, 2025.</a:t>
+            </a:r>
+          </a:p>
+          <a:p>
+            <a:pPr marL="0" lvl="0" indent="0">
+              <a:spcAft>
+                <a:spcPts val="1200"/>
+              </a:spcAft>
+              <a:buNone/>
+            </a:pPr>
+            <a:r>
+              <a:rPr lang="en-IN" sz="1000" dirty="0">
+                <a:hlinkClick r:id="rId4" action="ppaction://hlinksldjump"/>
+              </a:rPr>
+              <a:t>[2]</a:t>
+            </a:r>
+            <a:r>
+              <a:rPr lang="en-IN" sz="1000" dirty="0"/>
+              <a:t> C.-Y. Wang, A. </a:t>
+            </a:r>
+            <a:r>
+              <a:rPr lang="en-IN" sz="1000" dirty="0" err="1"/>
+              <a:t>Bochkovskiy</a:t>
+            </a:r>
+            <a:r>
+              <a:rPr lang="en-IN" sz="1000" dirty="0"/>
+              <a:t>, and H.-Y. M. Liao, “Yolov7: Trainable bag-of-freebies sets new state-of-the-art for real-time object detectors,” </a:t>
+            </a:r>
+            <a:r>
+              <a:rPr lang="en-IN" sz="1000" dirty="0" err="1"/>
+              <a:t>arXiv</a:t>
+            </a:r>
+            <a:r>
+              <a:rPr lang="en-IN" sz="1000" dirty="0"/>
+              <a:t> preprintarXiv:2207.02696, 2022.</a:t>
+            </a:r>
+          </a:p>
+          <a:p>
+            <a:pPr marL="0" lvl="0" indent="0">
+              <a:spcAft>
+                <a:spcPts val="1200"/>
+              </a:spcAft>
+              <a:buNone/>
+            </a:pPr>
+            <a:r>
+              <a:rPr lang="en-IN" sz="1000" dirty="0">
+                <a:hlinkClick r:id="rId4" action="ppaction://hlinksldjump"/>
+              </a:rPr>
+              <a:t>[3]</a:t>
+            </a:r>
+            <a:r>
+              <a:rPr lang="en-IN" sz="1000" dirty="0"/>
+              <a:t> M. Yaseen, “What is yolov8: An in-depth exploration of the internal features of </a:t>
+            </a:r>
+            <a:r>
+              <a:rPr lang="en-IN" sz="1000" dirty="0" err="1"/>
+              <a:t>thenext</a:t>
+            </a:r>
+            <a:r>
+              <a:rPr lang="en-IN" sz="1000" dirty="0"/>
+              <a:t>-generation object detector,” </a:t>
+            </a:r>
+            <a:r>
+              <a:rPr lang="en-IN" sz="1000" dirty="0" err="1"/>
+              <a:t>arXiv</a:t>
+            </a:r>
+            <a:r>
+              <a:rPr lang="en-IN" sz="1000" dirty="0"/>
+              <a:t> preprint arXiv:2408.15857, 2024.</a:t>
+            </a:r>
+          </a:p>
+          <a:p>
+            <a:pPr marL="0" lvl="0" indent="0">
+              <a:spcAft>
+                <a:spcPts val="1200"/>
+              </a:spcAft>
+              <a:buNone/>
+            </a:pPr>
+            <a:r>
+              <a:rPr lang="en-IN" sz="1000" dirty="0">
+                <a:hlinkClick r:id="rId4" action="ppaction://hlinksldjump"/>
+              </a:rPr>
+              <a:t>[4]</a:t>
+            </a:r>
+            <a:r>
+              <a:rPr lang="en-IN" sz="1000" dirty="0"/>
+              <a:t> D. </a:t>
+            </a:r>
+            <a:r>
+              <a:rPr lang="en-IN" sz="1000" dirty="0" err="1"/>
+              <a:t>Gragnaniello</a:t>
+            </a:r>
+            <a:r>
+              <a:rPr lang="en-IN" sz="1000" dirty="0"/>
+              <a:t>, A. Greco, C. Sansone, and B. Vento, “FLAME: fire detection </a:t>
+            </a:r>
+            <a:r>
+              <a:rPr lang="en-IN" sz="1000" dirty="0" err="1"/>
+              <a:t>invideos</a:t>
+            </a:r>
+            <a:r>
+              <a:rPr lang="en-IN" sz="1000" dirty="0"/>
+              <a:t> combining a deep neural network with a model-based motion analysis,” </a:t>
+            </a:r>
+            <a:r>
+              <a:rPr lang="en-IN" sz="1000" dirty="0" err="1"/>
+              <a:t>NeuralComputing</a:t>
+            </a:r>
+            <a:r>
+              <a:rPr lang="en-IN" sz="1000" dirty="0"/>
+              <a:t> and Applications, vol. 37, pp. 6181–6197, 2025.</a:t>
+            </a:r>
+          </a:p>
+          <a:p>
+            <a:pPr marL="0" lvl="0" indent="0">
+              <a:spcAft>
+                <a:spcPts val="1200"/>
+              </a:spcAft>
+              <a:buNone/>
+            </a:pPr>
+            <a:r>
+              <a:rPr lang="en-IN" sz="1000" dirty="0">
+                <a:hlinkClick r:id="rId4" action="ppaction://hlinksldjump"/>
+              </a:rPr>
+              <a:t>[5]</a:t>
+            </a:r>
+            <a:r>
+              <a:rPr lang="en-IN" sz="1000" dirty="0"/>
+              <a:t> A. </a:t>
+            </a:r>
+            <a:r>
+              <a:rPr lang="en-IN" sz="1000" dirty="0" err="1"/>
+              <a:t>Joemon</a:t>
+            </a:r>
+            <a:r>
+              <a:rPr lang="en-IN" sz="1000" dirty="0"/>
+              <a:t>, A. C. Joy, A. V. Prakash, B. Thomas, and D. R, “Abnormal event </a:t>
+            </a:r>
+            <a:r>
+              <a:rPr lang="en-IN" sz="1000" dirty="0" err="1"/>
+              <a:t>detec-tion</a:t>
+            </a:r>
+            <a:r>
+              <a:rPr lang="en-IN" sz="1000" dirty="0"/>
+              <a:t> using </a:t>
+            </a:r>
+            <a:r>
+              <a:rPr lang="en-IN" sz="1000" dirty="0" err="1"/>
+              <a:t>cctv</a:t>
+            </a:r>
+            <a:r>
+              <a:rPr lang="en-IN" sz="1000" dirty="0"/>
+              <a:t> camera,” International Journal of Innovative Science and </a:t>
+            </a:r>
+            <a:r>
+              <a:rPr lang="en-IN" sz="1000" dirty="0" err="1"/>
+              <a:t>ResearchTechnology</a:t>
+            </a:r>
+            <a:r>
+              <a:rPr lang="en-IN" sz="1000" dirty="0"/>
+              <a:t> (IJISRT), vol. 6, no. 6, pp. 608–612, 2021.</a:t>
+            </a:r>
+          </a:p>
+          <a:p>
+            <a:pPr marL="0" lvl="0" indent="0">
+              <a:spcAft>
+                <a:spcPts val="1200"/>
+              </a:spcAft>
+              <a:buNone/>
+            </a:pPr>
+            <a:r>
+              <a:rPr lang="en-IN" sz="1000" dirty="0">
+                <a:hlinkClick r:id="rId3" action="ppaction://hlinksldjump"/>
+              </a:rPr>
+              <a:t>[6]</a:t>
+            </a:r>
+            <a:r>
+              <a:rPr lang="en-IN" sz="1000" dirty="0"/>
+              <a:t> M. Wang, Y. Zhang, Q. Zhao, J. Yang, and H. Zhang, “Redefining </a:t>
+            </a:r>
+            <a:r>
+              <a:rPr lang="en-IN" sz="1000" dirty="0" err="1"/>
+              <a:t>informa-tion</a:t>
+            </a:r>
+            <a:r>
+              <a:rPr lang="en-IN" sz="1000" dirty="0"/>
+              <a:t> retrieval of structured database via large language models,” </a:t>
+            </a:r>
+            <a:r>
+              <a:rPr lang="en-IN" sz="1000" dirty="0" err="1"/>
+              <a:t>arXiv</a:t>
+            </a:r>
+            <a:r>
+              <a:rPr lang="en-IN" sz="1000" dirty="0"/>
+              <a:t> preprintarXiv:2405.05508, 2024.</a:t>
+            </a:r>
+          </a:p>
+          <a:p>
+            <a:pPr marL="0" lvl="0" indent="0">
+              <a:spcAft>
+                <a:spcPts val="1200"/>
+              </a:spcAft>
+              <a:buNone/>
+            </a:pPr>
+            <a:r>
+              <a:rPr lang="en-IN" sz="1000" dirty="0">
+                <a:hlinkClick r:id="rId3" action="ppaction://hlinksldjump"/>
+              </a:rPr>
+              <a:t>[7]</a:t>
+            </a:r>
+            <a:r>
+              <a:rPr lang="en-IN" sz="1000" dirty="0"/>
+              <a:t> J. Myung, J. Park, S. Park, K. Lee, H. Kim, and S. Lee, “Hyst: </a:t>
+            </a:r>
+            <a:r>
+              <a:rPr lang="en-IN" sz="1000" dirty="0" err="1"/>
+              <a:t>Llm-poweredhybrid</a:t>
+            </a:r>
+            <a:r>
+              <a:rPr lang="en-IN" sz="1000" dirty="0"/>
+              <a:t> retrieval over semi-structured tabular data,” in Proceedings of the 2nd </a:t>
+            </a:r>
+            <a:r>
+              <a:rPr lang="en-IN" sz="1000" dirty="0" err="1"/>
+              <a:t>EARLWorkshop</a:t>
+            </a:r>
+            <a:r>
+              <a:rPr lang="en-IN" sz="1000" dirty="0"/>
+              <a:t> on Evaluating and Applying Recommender Systems with LLMs, 2025.16</a:t>
+            </a:r>
+          </a:p>
+        </p:txBody>
+      </p:sp>
+    </p:spTree>
+  </p:cSld>
+  <p:clrMapOvr>
+    <a:masterClrMapping/>
+  </p:clrMapOvr>
+</p:sld>
+</file>
+
+<file path=ppt/slides/slide21.xml><?xml version="1.0" encoding="utf-8"?>
 <p:sld xmlns:a="http://schemas.openxmlformats.org/drawingml/2006/main" xmlns:r="http://schemas.openxmlformats.org/officeDocument/2006/relationships" xmlns:p="http://schemas.openxmlformats.org/presentationml/2006/main">
   <p:cSld>
     <p:spTree>
@@ -10152,7 +10160,7 @@
 </p:sld>
 </file>
 
-<file path=ppt/slides/slide21.xml><?xml version="1.0" encoding="utf-8"?>
+<file path=ppt/slides/slide22.xml><?xml version="1.0" encoding="utf-8"?>
 <p:sld xmlns:a="http://schemas.openxmlformats.org/drawingml/2006/main" xmlns:r="http://schemas.openxmlformats.org/officeDocument/2006/relationships" xmlns:p="http://schemas.openxmlformats.org/presentationml/2006/main">
   <p:cSld>
     <p:spTree>
@@ -10177,8 +10185,8 @@
         </p:nvSpPr>
         <p:spPr>
           <a:xfrm>
-            <a:off x="2637700" y="2110050"/>
-            <a:ext cx="2772900" cy="461700"/>
+            <a:off x="2359630" y="2263988"/>
+            <a:ext cx="4424739" cy="615523"/>
           </a:xfrm>
           <a:prstGeom prst="rect">
             <a:avLst/>
@@ -10204,14 +10212,14 @@
               <a:buNone/>
             </a:pPr>
             <a:r>
-              <a:rPr lang="en-GB" sz="1800">
+              <a:rPr lang="en-GB" sz="2800" b="1" dirty="0">
                 <a:solidFill>
                   <a:schemeClr val="dk2"/>
                 </a:solidFill>
               </a:rPr>
               <a:t>Questions / Discussions </a:t>
             </a:r>
-            <a:endParaRPr sz="1800">
+            <a:endParaRPr sz="2800" b="1" dirty="0">
               <a:solidFill>
                 <a:schemeClr val="dk2"/>
               </a:solidFill>
@@ -10227,7 +10235,7 @@
 </p:sld>
 </file>
 
-<file path=ppt/slides/slide22.xml><?xml version="1.0" encoding="utf-8"?>
+<file path=ppt/slides/slide23.xml><?xml version="1.0" encoding="utf-8"?>
 <p:sld xmlns:a="http://schemas.openxmlformats.org/drawingml/2006/main" xmlns:r="http://schemas.openxmlformats.org/officeDocument/2006/relationships" xmlns:p="http://schemas.openxmlformats.org/presentationml/2006/main">
   <p:cSld>
     <p:spTree>
@@ -10252,8 +10260,8 @@
         </p:nvSpPr>
         <p:spPr>
           <a:xfrm>
-            <a:off x="3829725" y="2196300"/>
-            <a:ext cx="1384800" cy="492600"/>
+            <a:off x="3791984" y="2263988"/>
+            <a:ext cx="1560031" cy="615523"/>
           </a:xfrm>
           <a:prstGeom prst="rect">
             <a:avLst/>
@@ -10279,14 +10287,14 @@
               <a:buNone/>
             </a:pPr>
             <a:r>
-              <a:rPr lang="en-GB" sz="2000" b="1">
+              <a:rPr lang="en-GB" sz="2800" b="1" dirty="0">
                 <a:solidFill>
                   <a:schemeClr val="dk2"/>
                 </a:solidFill>
               </a:rPr>
               <a:t>Thanks</a:t>
             </a:r>
-            <a:endParaRPr sz="2000" b="1">
+            <a:endParaRPr sz="2800" b="1" dirty="0">
               <a:solidFill>
                 <a:schemeClr val="dk2"/>
               </a:solidFill>
@@ -10354,10 +10362,10 @@
               <a:buNone/>
             </a:pPr>
             <a:r>
-              <a:rPr lang="en-GB"/>
+              <a:rPr lang="en-GB" sz="3100" b="1" dirty="0"/>
               <a:t>Objectives</a:t>
             </a:r>
-            <a:endParaRPr/>
+            <a:endParaRPr sz="3100" b="1" dirty="0"/>
           </a:p>
           <a:p>
             <a:pPr marL="0" lvl="0" indent="0" algn="l" rtl="0">
@@ -10369,7 +10377,7 @@
               </a:spcAft>
               <a:buNone/>
             </a:pPr>
-            <a:endParaRPr/>
+            <a:endParaRPr dirty="0"/>
           </a:p>
           <a:p>
             <a:pPr marL="0" lvl="0" indent="0" algn="l" rtl="0">
@@ -10381,7 +10389,7 @@
               </a:spcAft>
               <a:buNone/>
             </a:pPr>
-            <a:endParaRPr/>
+            <a:endParaRPr dirty="0"/>
           </a:p>
         </p:txBody>
       </p:sp>
@@ -10406,7 +10414,7 @@
         </p:spPr>
         <p:txBody>
           <a:bodyPr spcFirstLastPara="1" wrap="square" lIns="91425" tIns="91425" rIns="91425" bIns="91425" anchor="t" anchorCtr="0">
-            <a:normAutofit/>
+            <a:noAutofit/>
           </a:bodyPr>
           <a:lstStyle/>
           <a:p>
@@ -10424,10 +10432,10 @@
               <a:buChar char="●"/>
             </a:pPr>
             <a:r>
-              <a:rPr lang="en-GB" sz="1500" dirty="0"/>
+              <a:rPr lang="en-GB" dirty="0"/>
               <a:t>Develop intelligent human language query mechanism for CCTV post analysis using LLM and modern Computer Vision models.</a:t>
             </a:r>
-            <a:endParaRPr sz="1500" dirty="0"/>
+            <a:endParaRPr dirty="0"/>
           </a:p>
           <a:p>
             <a:pPr marL="457200" lvl="0" indent="-342900" algn="l" rtl="0">
@@ -10444,10 +10452,10 @@
               <a:buChar char="●"/>
             </a:pPr>
             <a:r>
-              <a:rPr lang="en-GB" sz="1500" dirty="0"/>
+              <a:rPr lang="en-GB" dirty="0"/>
               <a:t>Implement seamless integration between CV models and Large Language Models to enable reasoning, summarization, and natural language querying.</a:t>
             </a:r>
-            <a:endParaRPr sz="1500" dirty="0"/>
+            <a:endParaRPr dirty="0"/>
           </a:p>
           <a:p>
             <a:pPr marL="457200" lvl="0" indent="-342900" algn="l" rtl="0">
@@ -10464,10 +10472,10 @@
               <a:buChar char="●"/>
             </a:pPr>
             <a:r>
-              <a:rPr lang="en-GB" sz="1500" dirty="0"/>
+              <a:rPr lang="en-GB" dirty="0"/>
               <a:t>Improve the efficiency and accuracy of surveillance analysis for both real-time and historical data.</a:t>
             </a:r>
-            <a:endParaRPr sz="1500" dirty="0"/>
+            <a:endParaRPr dirty="0"/>
           </a:p>
           <a:p>
             <a:pPr marL="457200" lvl="0" indent="-342900" algn="l" rtl="0">
@@ -10484,10 +10492,10 @@
               <a:buChar char="●"/>
             </a:pPr>
             <a:r>
-              <a:rPr lang="en-GB" sz="1500" dirty="0"/>
+              <a:rPr lang="en-GB" dirty="0"/>
               <a:t>Enable comprehensive, time-stamped analysis of historical surveillance events through LLM-based querying.</a:t>
             </a:r>
-            <a:endParaRPr sz="1500" dirty="0"/>
+            <a:endParaRPr dirty="0"/>
           </a:p>
           <a:p>
             <a:pPr marL="457200" lvl="0" indent="0" algn="l" rtl="0">
@@ -10502,7 +10510,7 @@
               </a:spcAft>
               <a:buNone/>
             </a:pPr>
-            <a:endParaRPr sz="1500" dirty="0"/>
+            <a:endParaRPr dirty="0"/>
           </a:p>
         </p:txBody>
       </p:sp>
@@ -11209,10 +11217,10 @@
               <a:buNone/>
             </a:pPr>
             <a:r>
-              <a:rPr lang="en-GB" dirty="0"/>
+              <a:rPr lang="en-GB" sz="3100" b="1" dirty="0"/>
               <a:t>Literature Review</a:t>
             </a:r>
-            <a:endParaRPr dirty="0"/>
+            <a:endParaRPr sz="3100" b="1" dirty="0"/>
           </a:p>
           <a:p>
             <a:pPr marL="0" lvl="0" indent="0" algn="l" rtl="0">
@@ -11255,14 +11263,14 @@
           <p:nvPr>
             <p:extLst>
               <p:ext uri="{D42A27DB-BD31-4B8C-83A1-F6EECF244321}">
-                <p14:modId xmlns:p14="http://schemas.microsoft.com/office/powerpoint/2010/main" val="1063966990"/>
+                <p14:modId xmlns:p14="http://schemas.microsoft.com/office/powerpoint/2010/main" val="1117937145"/>
               </p:ext>
             </p:extLst>
           </p:nvPr>
         </p:nvGraphicFramePr>
         <p:xfrm>
           <a:off x="436086" y="1071059"/>
-          <a:ext cx="7964202" cy="3561901"/>
+          <a:ext cx="7964202" cy="3606098"/>
         </p:xfrm>
         <a:graphic>
           <a:graphicData uri="http://schemas.openxmlformats.org/drawingml/2006/table">
@@ -11322,7 +11330,11 @@
                         <a:buNone/>
                       </a:pPr>
                       <a:r>
-                        <a:rPr lang="en-IN" sz="800" dirty="0"/>
+                        <a:rPr lang="en-IN" sz="1200" dirty="0">
+                          <a:solidFill>
+                            <a:schemeClr val="bg2"/>
+                          </a:solidFill>
+                        </a:rPr>
                         <a:t>Sr.</a:t>
                       </a:r>
                     </a:p>
@@ -11376,7 +11388,11 @@
                         <a:buNone/>
                       </a:pPr>
                       <a:r>
-                        <a:rPr lang="en-IN" sz="800" dirty="0"/>
+                        <a:rPr lang="en-IN" sz="1200" dirty="0">
+                          <a:solidFill>
+                            <a:schemeClr val="bg2"/>
+                          </a:solidFill>
+                        </a:rPr>
                         <a:t>Title</a:t>
                       </a:r>
                     </a:p>
@@ -11430,7 +11446,11 @@
                         <a:buNone/>
                       </a:pPr>
                       <a:r>
-                        <a:rPr lang="en-IN" sz="800"/>
+                        <a:rPr lang="en-IN" sz="1200">
+                          <a:solidFill>
+                            <a:schemeClr val="bg2"/>
+                          </a:solidFill>
+                        </a:rPr>
                         <a:t>Dataset</a:t>
                       </a:r>
                     </a:p>
@@ -11484,7 +11504,11 @@
                         <a:buNone/>
                       </a:pPr>
                       <a:r>
-                        <a:rPr lang="en-IN" sz="800"/>
+                        <a:rPr lang="en-IN" sz="1200">
+                          <a:solidFill>
+                            <a:schemeClr val="bg2"/>
+                          </a:solidFill>
+                        </a:rPr>
                         <a:t>Model / Core Tech</a:t>
                       </a:r>
                     </a:p>
@@ -11538,7 +11562,11 @@
                         <a:buNone/>
                       </a:pPr>
                       <a:r>
-                        <a:rPr lang="en-IN" sz="800"/>
+                        <a:rPr lang="en-IN" sz="1200">
+                          <a:solidFill>
+                            <a:schemeClr val="bg2"/>
+                          </a:solidFill>
+                        </a:rPr>
                         <a:t>Take Away</a:t>
                       </a:r>
                     </a:p>
@@ -11592,7 +11620,11 @@
                         <a:buNone/>
                       </a:pPr>
                       <a:r>
-                        <a:rPr lang="en-IN" sz="800" dirty="0"/>
+                        <a:rPr lang="en-IN" sz="1200" dirty="0">
+                          <a:solidFill>
+                            <a:schemeClr val="bg2"/>
+                          </a:solidFill>
+                        </a:rPr>
                         <a:t>Ref.</a:t>
                       </a:r>
                     </a:p>
@@ -11653,10 +11685,18 @@
                         <a:buNone/>
                       </a:pPr>
                       <a:r>
-                        <a:rPr lang="en-US" sz="800" dirty="0"/>
+                        <a:rPr lang="en-US" sz="1200" dirty="0">
+                          <a:solidFill>
+                            <a:schemeClr val="bg2"/>
+                          </a:solidFill>
+                        </a:rPr>
                         <a:t>1</a:t>
                       </a:r>
-                      <a:endParaRPr lang="en-IN" sz="800" dirty="0"/>
+                      <a:endParaRPr lang="en-IN" sz="1200" dirty="0">
+                        <a:solidFill>
+                          <a:schemeClr val="bg2"/>
+                        </a:solidFill>
+                      </a:endParaRPr>
                     </a:p>
                   </a:txBody>
                   <a:tcPr marL="18367" marR="18367" marT="9184" marB="9184" anchor="ctr">
@@ -11708,7 +11748,11 @@
                         <a:buNone/>
                       </a:pPr>
                       <a:r>
-                        <a:rPr lang="en-IN" sz="800" dirty="0"/>
+                        <a:rPr lang="en-IN" sz="1200" dirty="0">
+                          <a:solidFill>
+                            <a:schemeClr val="bg2"/>
+                          </a:solidFill>
+                        </a:rPr>
                         <a:t>YOLOv7 Real-time Object Detection</a:t>
                       </a:r>
                     </a:p>
@@ -11762,7 +11806,11 @@
                         <a:buNone/>
                       </a:pPr>
                       <a:r>
-                        <a:rPr lang="en-IN" sz="800" dirty="0"/>
+                        <a:rPr lang="en-IN" sz="1200" dirty="0">
+                          <a:solidFill>
+                            <a:schemeClr val="bg2"/>
+                          </a:solidFill>
+                        </a:rPr>
                         <a:t>MS COCO</a:t>
                       </a:r>
                     </a:p>
@@ -11816,7 +11864,11 @@
                         <a:buNone/>
                       </a:pPr>
                       <a:r>
-                        <a:rPr lang="en-IN" sz="800" dirty="0"/>
+                        <a:rPr lang="en-IN" sz="1200" dirty="0">
+                          <a:solidFill>
+                            <a:schemeClr val="bg2"/>
+                          </a:solidFill>
+                        </a:rPr>
                         <a:t>YOLOv7</a:t>
                       </a:r>
                     </a:p>
@@ -11870,7 +11922,11 @@
                         <a:buNone/>
                       </a:pPr>
                       <a:r>
-                        <a:rPr lang="en-US" sz="800"/>
+                        <a:rPr lang="en-US" sz="1200">
+                          <a:solidFill>
+                            <a:schemeClr val="bg2"/>
+                          </a:solidFill>
+                        </a:rPr>
                         <a:t>High-accuracy, real-time detector suitable for CCTV feeds; validates real-time event detection feasibility</a:t>
                       </a:r>
                     </a:p>
@@ -11924,18 +11980,40 @@
                         <a:buNone/>
                       </a:pPr>
                       <a:r>
-                        <a:rPr lang="en-US" sz="800" dirty="0">
-                          <a:hlinkClick r:id="rId2" action="ppaction://hlinksldjump"/>
+                        <a:rPr lang="en-US" sz="1200" dirty="0">
+                          <a:solidFill>
+                            <a:srgbClr val="0097A7"/>
+                          </a:solidFill>
+                          <a:hlinkClick r:id="rId2" action="ppaction://hlinksldjump">
+                            <a:extLst>
+                              <a:ext uri="{A12FA001-AC4F-418D-AE19-62706E023703}">
+                                <ahyp:hlinkClr xmlns:ahyp="http://schemas.microsoft.com/office/drawing/2018/hyperlinkcolor" val="tx"/>
+                              </a:ext>
+                            </a:extLst>
+                          </a:hlinkClick>
                         </a:rPr>
                         <a:t>[2</a:t>
                       </a:r>
                       <a:r>
-                        <a:rPr lang="en-IN" sz="800" dirty="0">
-                          <a:hlinkClick r:id="rId2" action="ppaction://hlinksldjump"/>
+                        <a:rPr lang="en-IN" sz="1200" dirty="0">
+                          <a:solidFill>
+                            <a:schemeClr val="bg2"/>
+                          </a:solidFill>
+                          <a:hlinkClick r:id="rId2" action="ppaction://hlinksldjump">
+                            <a:extLst>
+                              <a:ext uri="{A12FA001-AC4F-418D-AE19-62706E023703}">
+                                <ahyp:hlinkClr xmlns:ahyp="http://schemas.microsoft.com/office/drawing/2018/hyperlinkcolor" val="tx"/>
+                              </a:ext>
+                            </a:extLst>
+                          </a:hlinkClick>
                         </a:rPr>
                         <a:t>]</a:t>
                       </a:r>
-                      <a:endParaRPr lang="en-IN" sz="800" dirty="0"/>
+                      <a:endParaRPr lang="en-IN" sz="1200" dirty="0">
+                        <a:solidFill>
+                          <a:schemeClr val="bg2"/>
+                        </a:solidFill>
+                      </a:endParaRPr>
                     </a:p>
                   </a:txBody>
                   <a:tcPr marL="18367" marR="18367" marT="9184" marB="9184" anchor="ctr">
@@ -11994,10 +12072,18 @@
                         <a:buNone/>
                       </a:pPr>
                       <a:r>
-                        <a:rPr lang="en-US" sz="800" dirty="0"/>
+                        <a:rPr lang="en-US" sz="1200" dirty="0">
+                          <a:solidFill>
+                            <a:schemeClr val="bg2"/>
+                          </a:solidFill>
+                        </a:rPr>
                         <a:t>2</a:t>
                       </a:r>
-                      <a:endParaRPr lang="en-IN" sz="800" dirty="0"/>
+                      <a:endParaRPr lang="en-IN" sz="1200" dirty="0">
+                        <a:solidFill>
+                          <a:schemeClr val="bg2"/>
+                        </a:solidFill>
+                      </a:endParaRPr>
                     </a:p>
                   </a:txBody>
                   <a:tcPr marL="18367" marR="18367" marT="9184" marB="9184" anchor="ctr">
@@ -12049,7 +12135,11 @@
                         <a:buNone/>
                       </a:pPr>
                       <a:r>
-                        <a:rPr lang="en-IN" sz="800" dirty="0"/>
+                        <a:rPr lang="en-IN" sz="1200" dirty="0">
+                          <a:solidFill>
+                            <a:schemeClr val="bg2"/>
+                          </a:solidFill>
+                        </a:rPr>
                         <a:t>YOLOv8 Feature Analysis</a:t>
                       </a:r>
                     </a:p>
@@ -12103,7 +12193,11 @@
                         <a:buNone/>
                       </a:pPr>
                       <a:r>
-                        <a:rPr lang="en-IN" sz="800"/>
+                        <a:rPr lang="en-IN" sz="1200" dirty="0">
+                          <a:solidFill>
+                            <a:schemeClr val="bg2"/>
+                          </a:solidFill>
+                        </a:rPr>
                         <a:t>MS COCO</a:t>
                       </a:r>
                     </a:p>
@@ -12157,7 +12251,11 @@
                         <a:buNone/>
                       </a:pPr>
                       <a:r>
-                        <a:rPr lang="en-IN" sz="800" dirty="0"/>
+                        <a:rPr lang="en-IN" sz="1200" dirty="0">
+                          <a:solidFill>
+                            <a:schemeClr val="bg2"/>
+                          </a:solidFill>
+                        </a:rPr>
                         <a:t>YOLOv8</a:t>
                       </a:r>
                     </a:p>
@@ -12211,7 +12309,11 @@
                         <a:buNone/>
                       </a:pPr>
                       <a:r>
-                        <a:rPr lang="en-US" sz="800"/>
+                        <a:rPr lang="en-US" sz="1200">
+                          <a:solidFill>
+                            <a:schemeClr val="bg2"/>
+                          </a:solidFill>
+                        </a:rPr>
                         <a:t>Strong detection performance; anchor-free design reduces computation for CCTV tasks</a:t>
                       </a:r>
                     </a:p>
@@ -12265,18 +12367,40 @@
                         <a:buNone/>
                       </a:pPr>
                       <a:r>
-                        <a:rPr lang="en-US" sz="800" dirty="0">
-                          <a:hlinkClick r:id="rId2" action="ppaction://hlinksldjump"/>
+                        <a:rPr lang="en-US" sz="1200" dirty="0">
+                          <a:solidFill>
+                            <a:srgbClr val="0097A7"/>
+                          </a:solidFill>
+                          <a:hlinkClick r:id="rId2" action="ppaction://hlinksldjump">
+                            <a:extLst>
+                              <a:ext uri="{A12FA001-AC4F-418D-AE19-62706E023703}">
+                                <ahyp:hlinkClr xmlns:ahyp="http://schemas.microsoft.com/office/drawing/2018/hyperlinkcolor" val="tx"/>
+                              </a:ext>
+                            </a:extLst>
+                          </a:hlinkClick>
                         </a:rPr>
                         <a:t>[3</a:t>
                       </a:r>
                       <a:r>
-                        <a:rPr lang="en-IN" sz="800" dirty="0">
-                          <a:hlinkClick r:id="rId2" action="ppaction://hlinksldjump"/>
+                        <a:rPr lang="en-IN" sz="1200" dirty="0">
+                          <a:solidFill>
+                            <a:schemeClr val="bg2"/>
+                          </a:solidFill>
+                          <a:hlinkClick r:id="rId2" action="ppaction://hlinksldjump">
+                            <a:extLst>
+                              <a:ext uri="{A12FA001-AC4F-418D-AE19-62706E023703}">
+                                <ahyp:hlinkClr xmlns:ahyp="http://schemas.microsoft.com/office/drawing/2018/hyperlinkcolor" val="tx"/>
+                              </a:ext>
+                            </a:extLst>
+                          </a:hlinkClick>
                         </a:rPr>
                         <a:t>]</a:t>
                       </a:r>
-                      <a:endParaRPr lang="en-IN" sz="800" dirty="0"/>
+                      <a:endParaRPr lang="en-IN" sz="1200" dirty="0">
+                        <a:solidFill>
+                          <a:schemeClr val="bg2"/>
+                        </a:solidFill>
+                      </a:endParaRPr>
                     </a:p>
                   </a:txBody>
                   <a:tcPr marL="18367" marR="18367" marT="9184" marB="9184" anchor="ctr">
@@ -12335,10 +12459,18 @@
                         <a:buNone/>
                       </a:pPr>
                       <a:r>
-                        <a:rPr lang="en-US" sz="800" dirty="0"/>
+                        <a:rPr lang="en-US" sz="1200" dirty="0">
+                          <a:solidFill>
+                            <a:schemeClr val="bg2"/>
+                          </a:solidFill>
+                        </a:rPr>
                         <a:t>3</a:t>
                       </a:r>
-                      <a:endParaRPr lang="en-IN" sz="800" dirty="0"/>
+                      <a:endParaRPr lang="en-IN" sz="1200" dirty="0">
+                        <a:solidFill>
+                          <a:schemeClr val="bg2"/>
+                        </a:solidFill>
+                      </a:endParaRPr>
                     </a:p>
                   </a:txBody>
                   <a:tcPr marL="18367" marR="18367" marT="9184" marB="9184" anchor="ctr">
@@ -12390,7 +12522,11 @@
                         <a:buNone/>
                       </a:pPr>
                       <a:r>
-                        <a:rPr lang="en-US" sz="800"/>
+                        <a:rPr lang="en-US" sz="1200">
+                          <a:solidFill>
+                            <a:schemeClr val="bg2"/>
+                          </a:solidFill>
+                        </a:rPr>
                         <a:t>FLAME: Fire Detection via DNN + Motion</a:t>
                       </a:r>
                     </a:p>
@@ -12444,7 +12580,11 @@
                         <a:buNone/>
                       </a:pPr>
                       <a:r>
-                        <a:rPr lang="en-IN" sz="800" dirty="0"/>
+                        <a:rPr lang="en-IN" sz="1200" dirty="0">
+                          <a:solidFill>
+                            <a:schemeClr val="bg2"/>
+                          </a:solidFill>
+                        </a:rPr>
                         <a:t>Fire datasets, LFDN</a:t>
                       </a:r>
                     </a:p>
@@ -12498,7 +12638,11 @@
                         <a:buNone/>
                       </a:pPr>
                       <a:r>
-                        <a:rPr lang="en-IN" sz="800"/>
+                        <a:rPr lang="en-IN" sz="1200">
+                          <a:solidFill>
+                            <a:schemeClr val="bg2"/>
+                          </a:solidFill>
+                        </a:rPr>
                         <a:t>YOLOv8 + Background Modeling</a:t>
                       </a:r>
                     </a:p>
@@ -12552,7 +12696,11 @@
                         <a:buNone/>
                       </a:pPr>
                       <a:r>
-                        <a:rPr lang="en-IN" sz="800" dirty="0"/>
+                        <a:rPr lang="en-IN" sz="1200" dirty="0">
+                          <a:solidFill>
+                            <a:schemeClr val="bg2"/>
+                          </a:solidFill>
+                        </a:rPr>
                         <a:t>Hybrid models reduce false positives; demonstrates domain-specific event detection reliability</a:t>
                       </a:r>
                     </a:p>
@@ -12606,12 +12754,25 @@
                         <a:buNone/>
                       </a:pPr>
                       <a:r>
-                        <a:rPr lang="en-US" sz="800" dirty="0">
-                          <a:hlinkClick r:id="rId2" action="ppaction://hlinksldjump"/>
+                        <a:rPr lang="en-US" sz="1200" dirty="0">
+                          <a:solidFill>
+                            <a:schemeClr val="bg2"/>
+                          </a:solidFill>
+                          <a:hlinkClick r:id="rId2" action="ppaction://hlinksldjump">
+                            <a:extLst>
+                              <a:ext uri="{A12FA001-AC4F-418D-AE19-62706E023703}">
+                                <ahyp:hlinkClr xmlns:ahyp="http://schemas.microsoft.com/office/drawing/2018/hyperlinkcolor" val="tx"/>
+                              </a:ext>
+                            </a:extLst>
+                          </a:hlinkClick>
                         </a:rPr>
                         <a:t>[4]</a:t>
                       </a:r>
-                      <a:endParaRPr lang="en-IN" sz="800" dirty="0"/>
+                      <a:endParaRPr lang="en-IN" sz="1200" dirty="0">
+                        <a:solidFill>
+                          <a:schemeClr val="bg2"/>
+                        </a:solidFill>
+                      </a:endParaRPr>
                     </a:p>
                   </a:txBody>
                   <a:tcPr marL="18367" marR="18367" marT="9184" marB="9184" anchor="ctr">
@@ -12670,10 +12831,18 @@
                         <a:buNone/>
                       </a:pPr>
                       <a:r>
-                        <a:rPr lang="en-US" sz="800" dirty="0"/>
+                        <a:rPr lang="en-US" sz="1200" dirty="0">
+                          <a:solidFill>
+                            <a:schemeClr val="bg2"/>
+                          </a:solidFill>
+                        </a:rPr>
                         <a:t>4</a:t>
                       </a:r>
-                      <a:endParaRPr lang="en-IN" sz="800" dirty="0"/>
+                      <a:endParaRPr lang="en-IN" sz="1200" dirty="0">
+                        <a:solidFill>
+                          <a:schemeClr val="bg2"/>
+                        </a:solidFill>
+                      </a:endParaRPr>
                     </a:p>
                   </a:txBody>
                   <a:tcPr marL="18367" marR="18367" marT="9184" marB="9184" anchor="ctr">
@@ -12725,7 +12894,11 @@
                         <a:buNone/>
                       </a:pPr>
                       <a:r>
-                        <a:rPr lang="en-US" sz="800" dirty="0"/>
+                        <a:rPr lang="en-US" sz="1200" dirty="0">
+                          <a:solidFill>
+                            <a:schemeClr val="bg2"/>
+                          </a:solidFill>
+                        </a:rPr>
                         <a:t>Abnormal Event Detection in CCTV</a:t>
                       </a:r>
                     </a:p>
@@ -12779,7 +12952,11 @@
                         <a:buNone/>
                       </a:pPr>
                       <a:r>
-                        <a:rPr lang="en-IN" sz="800" dirty="0"/>
+                        <a:rPr lang="en-IN" sz="1200" dirty="0">
+                          <a:solidFill>
+                            <a:schemeClr val="bg2"/>
+                          </a:solidFill>
+                        </a:rPr>
                         <a:t>UCSD, Avenue</a:t>
                       </a:r>
                     </a:p>
@@ -12833,7 +13010,11 @@
                         <a:buNone/>
                       </a:pPr>
                       <a:r>
-                        <a:rPr lang="en-IN" sz="800" dirty="0"/>
+                        <a:rPr lang="en-IN" sz="1200" dirty="0">
+                          <a:solidFill>
+                            <a:schemeClr val="bg2"/>
+                          </a:solidFill>
+                        </a:rPr>
                         <a:t>CNN–LSTM Autoencoder</a:t>
                       </a:r>
                     </a:p>
@@ -12887,14 +13068,26 @@
                         <a:buNone/>
                       </a:pPr>
                       <a:r>
-                        <a:rPr lang="en-IN" sz="800" dirty="0"/>
+                        <a:rPr lang="en-IN" sz="1200" dirty="0">
+                          <a:solidFill>
+                            <a:schemeClr val="bg2"/>
+                          </a:solidFill>
+                        </a:rPr>
                         <a:t>Detects anomalies via reconstruction error; supports temporal event </a:t>
                       </a:r>
                       <a:r>
-                        <a:rPr lang="en-IN" sz="800" dirty="0" err="1"/>
+                        <a:rPr lang="en-IN" sz="1200" dirty="0" err="1">
+                          <a:solidFill>
+                            <a:schemeClr val="bg2"/>
+                          </a:solidFill>
+                        </a:rPr>
                         <a:t>modeling</a:t>
                       </a:r>
-                      <a:endParaRPr lang="en-IN" sz="800" dirty="0"/>
+                      <a:endParaRPr lang="en-IN" sz="1200" dirty="0">
+                        <a:solidFill>
+                          <a:schemeClr val="bg2"/>
+                        </a:solidFill>
+                      </a:endParaRPr>
                     </a:p>
                   </a:txBody>
                   <a:tcPr marL="18367" marR="18367" marT="9184" marB="9184" anchor="ctr">
@@ -12946,18 +13139,40 @@
                         <a:buNone/>
                       </a:pPr>
                       <a:r>
-                        <a:rPr lang="en-US" sz="800" dirty="0">
-                          <a:hlinkClick r:id="rId2" action="ppaction://hlinksldjump"/>
+                        <a:rPr lang="en-US" sz="1200" dirty="0">
+                          <a:solidFill>
+                            <a:srgbClr val="0097A7"/>
+                          </a:solidFill>
+                          <a:hlinkClick r:id="rId2" action="ppaction://hlinksldjump">
+                            <a:extLst>
+                              <a:ext uri="{A12FA001-AC4F-418D-AE19-62706E023703}">
+                                <ahyp:hlinkClr xmlns:ahyp="http://schemas.microsoft.com/office/drawing/2018/hyperlinkcolor" val="tx"/>
+                              </a:ext>
+                            </a:extLst>
+                          </a:hlinkClick>
                         </a:rPr>
                         <a:t>[5</a:t>
                       </a:r>
                       <a:r>
-                        <a:rPr lang="en-IN" sz="800" dirty="0">
-                          <a:hlinkClick r:id="rId2" action="ppaction://hlinksldjump"/>
+                        <a:rPr lang="en-IN" sz="1200" dirty="0">
+                          <a:solidFill>
+                            <a:schemeClr val="bg2"/>
+                          </a:solidFill>
+                          <a:hlinkClick r:id="rId2" action="ppaction://hlinksldjump">
+                            <a:extLst>
+                              <a:ext uri="{A12FA001-AC4F-418D-AE19-62706E023703}">
+                                <ahyp:hlinkClr xmlns:ahyp="http://schemas.microsoft.com/office/drawing/2018/hyperlinkcolor" val="tx"/>
+                              </a:ext>
+                            </a:extLst>
+                          </a:hlinkClick>
                         </a:rPr>
                         <a:t>]</a:t>
                       </a:r>
-                      <a:endParaRPr lang="en-IN" sz="800" dirty="0"/>
+                      <a:endParaRPr lang="en-IN" sz="1200" dirty="0">
+                        <a:solidFill>
+                          <a:schemeClr val="bg2"/>
+                        </a:solidFill>
+                      </a:endParaRPr>
                     </a:p>
                   </a:txBody>
                   <a:tcPr marL="18367" marR="18367" marT="9184" marB="9184" anchor="ctr">
@@ -13016,10 +13231,18 @@
                         <a:buNone/>
                       </a:pPr>
                       <a:r>
-                        <a:rPr lang="en-US" sz="800" dirty="0"/>
+                        <a:rPr lang="en-US" sz="1200" dirty="0">
+                          <a:solidFill>
+                            <a:schemeClr val="bg2"/>
+                          </a:solidFill>
+                        </a:rPr>
                         <a:t>5</a:t>
                       </a:r>
-                      <a:endParaRPr lang="en-IN" sz="800" dirty="0"/>
+                      <a:endParaRPr lang="en-IN" sz="1200" dirty="0">
+                        <a:solidFill>
+                          <a:schemeClr val="bg2"/>
+                        </a:solidFill>
+                      </a:endParaRPr>
                     </a:p>
                   </a:txBody>
                   <a:tcPr marL="18367" marR="18367" marT="9184" marB="9184" anchor="ctr">
@@ -13071,7 +13294,11 @@
                         <a:buNone/>
                       </a:pPr>
                       <a:r>
-                        <a:rPr lang="en-IN" sz="800" dirty="0"/>
+                        <a:rPr lang="en-IN" sz="1200" dirty="0">
+                          <a:solidFill>
+                            <a:schemeClr val="bg2"/>
+                          </a:solidFill>
+                        </a:rPr>
                         <a:t>Surveillance Event Detection Review</a:t>
                       </a:r>
                     </a:p>
@@ -13125,14 +13352,26 @@
                         <a:buNone/>
                       </a:pPr>
                       <a:r>
-                        <a:rPr lang="en-IN" sz="800" dirty="0"/>
+                        <a:rPr lang="en-IN" sz="1200" dirty="0">
+                          <a:solidFill>
+                            <a:schemeClr val="bg2"/>
+                          </a:solidFill>
+                        </a:rPr>
                         <a:t>TRECVID SED, </a:t>
                       </a:r>
                       <a:r>
-                        <a:rPr lang="en-IN" sz="800" dirty="0" err="1"/>
+                        <a:rPr lang="en-IN" sz="1200" dirty="0" err="1">
+                          <a:solidFill>
+                            <a:schemeClr val="bg2"/>
+                          </a:solidFill>
+                        </a:rPr>
                         <a:t>ActEV</a:t>
                       </a:r>
-                      <a:endParaRPr lang="en-IN" sz="800" dirty="0"/>
+                      <a:endParaRPr lang="en-IN" sz="1200" dirty="0">
+                        <a:solidFill>
+                          <a:schemeClr val="bg2"/>
+                        </a:solidFill>
+                      </a:endParaRPr>
                     </a:p>
                   </a:txBody>
                   <a:tcPr marL="18367" marR="18367" marT="9184" marB="9184" anchor="ctr">
@@ -13184,7 +13423,11 @@
                         <a:buNone/>
                       </a:pPr>
                       <a:r>
-                        <a:rPr lang="en-IN" sz="800" dirty="0"/>
+                        <a:rPr lang="en-IN" sz="1200" dirty="0">
+                          <a:solidFill>
+                            <a:schemeClr val="bg2"/>
+                          </a:solidFill>
+                        </a:rPr>
                         <a:t>3D CNNs + Multi-stage Detectors</a:t>
                       </a:r>
                     </a:p>
@@ -13238,7 +13481,11 @@
                         <a:buNone/>
                       </a:pPr>
                       <a:r>
-                        <a:rPr lang="en-IN" sz="800" dirty="0"/>
+                        <a:rPr lang="en-IN" sz="1200" dirty="0">
+                          <a:solidFill>
+                            <a:schemeClr val="bg2"/>
+                          </a:solidFill>
+                        </a:rPr>
                         <a:t>Reinforces complexity of surveillance events; validates modular CV–LLM pipeline</a:t>
                       </a:r>
                     </a:p>
@@ -13292,12 +13539,25 @@
                         <a:buNone/>
                       </a:pPr>
                       <a:r>
-                        <a:rPr lang="en-US" sz="800" dirty="0">
-                          <a:hlinkClick r:id="rId3" action="ppaction://hlinksldjump"/>
+                        <a:rPr lang="en-US" sz="1200" dirty="0">
+                          <a:solidFill>
+                            <a:schemeClr val="bg2"/>
+                          </a:solidFill>
+                          <a:hlinkClick r:id="rId3" action="ppaction://hlinksldjump">
+                            <a:extLst>
+                              <a:ext uri="{A12FA001-AC4F-418D-AE19-62706E023703}">
+                                <ahyp:hlinkClr xmlns:ahyp="http://schemas.microsoft.com/office/drawing/2018/hyperlinkcolor" val="tx"/>
+                              </a:ext>
+                            </a:extLst>
+                          </a:hlinkClick>
                         </a:rPr>
                         <a:t>[10]</a:t>
                       </a:r>
-                      <a:endParaRPr lang="en-IN" sz="800" dirty="0"/>
+                      <a:endParaRPr lang="en-IN" sz="1200" dirty="0">
+                        <a:solidFill>
+                          <a:schemeClr val="bg2"/>
+                        </a:solidFill>
+                      </a:endParaRPr>
                     </a:p>
                   </a:txBody>
                   <a:tcPr marL="18367" marR="18367" marT="9184" marB="9184" anchor="ctr">
@@ -14058,10 +14318,10 @@
               <a:buNone/>
             </a:pPr>
             <a:r>
-              <a:rPr lang="en-GB" dirty="0"/>
+              <a:rPr lang="en-GB" sz="3100" b="1" dirty="0"/>
               <a:t>Literature Review</a:t>
             </a:r>
-            <a:endParaRPr dirty="0"/>
+            <a:endParaRPr sz="3100" b="1" dirty="0"/>
           </a:p>
           <a:p>
             <a:pPr marL="0" lvl="0" indent="0" algn="l" rtl="0">
@@ -14104,14 +14364,14 @@
           <p:nvPr>
             <p:extLst>
               <p:ext uri="{D42A27DB-BD31-4B8C-83A1-F6EECF244321}">
-                <p14:modId xmlns:p14="http://schemas.microsoft.com/office/powerpoint/2010/main" val="2120738696"/>
+                <p14:modId xmlns:p14="http://schemas.microsoft.com/office/powerpoint/2010/main" val="2987532648"/>
               </p:ext>
             </p:extLst>
           </p:nvPr>
         </p:nvGraphicFramePr>
         <p:xfrm>
           <a:off x="405606" y="1017588"/>
-          <a:ext cx="7906973" cy="3681411"/>
+          <a:ext cx="7906973" cy="4026507"/>
         </p:xfrm>
         <a:graphic>
           <a:graphicData uri="http://schemas.openxmlformats.org/drawingml/2006/table">
@@ -14171,7 +14431,11 @@
                         <a:buNone/>
                       </a:pPr>
                       <a:r>
-                        <a:rPr lang="en-IN" sz="800" dirty="0"/>
+                        <a:rPr lang="en-IN" sz="1200" dirty="0">
+                          <a:solidFill>
+                            <a:schemeClr val="bg2"/>
+                          </a:solidFill>
+                        </a:rPr>
                         <a:t>Sr.</a:t>
                       </a:r>
                     </a:p>
@@ -14225,7 +14489,11 @@
                         <a:buNone/>
                       </a:pPr>
                       <a:r>
-                        <a:rPr lang="en-IN" sz="800"/>
+                        <a:rPr lang="en-IN" sz="1200">
+                          <a:solidFill>
+                            <a:schemeClr val="bg2"/>
+                          </a:solidFill>
+                        </a:rPr>
                         <a:t>Title</a:t>
                       </a:r>
                     </a:p>
@@ -14279,7 +14547,11 @@
                         <a:buNone/>
                       </a:pPr>
                       <a:r>
-                        <a:rPr lang="en-IN" sz="800"/>
+                        <a:rPr lang="en-IN" sz="1200">
+                          <a:solidFill>
+                            <a:schemeClr val="bg2"/>
+                          </a:solidFill>
+                        </a:rPr>
                         <a:t>Dataset</a:t>
                       </a:r>
                     </a:p>
@@ -14333,7 +14605,11 @@
                         <a:buNone/>
                       </a:pPr>
                       <a:r>
-                        <a:rPr lang="en-IN" sz="800"/>
+                        <a:rPr lang="en-IN" sz="1200">
+                          <a:solidFill>
+                            <a:schemeClr val="bg2"/>
+                          </a:solidFill>
+                        </a:rPr>
                         <a:t>Model / Core Tech</a:t>
                       </a:r>
                     </a:p>
@@ -14387,7 +14663,11 @@
                         <a:buNone/>
                       </a:pPr>
                       <a:r>
-                        <a:rPr lang="en-IN" sz="800"/>
+                        <a:rPr lang="en-IN" sz="1200">
+                          <a:solidFill>
+                            <a:schemeClr val="bg2"/>
+                          </a:solidFill>
+                        </a:rPr>
                         <a:t>Take Away</a:t>
                       </a:r>
                     </a:p>
@@ -14441,7 +14721,11 @@
                         <a:buNone/>
                       </a:pPr>
                       <a:r>
-                        <a:rPr lang="en-IN" sz="800" dirty="0"/>
+                        <a:rPr lang="en-IN" sz="1200" dirty="0">
+                          <a:solidFill>
+                            <a:schemeClr val="bg2"/>
+                          </a:solidFill>
+                        </a:rPr>
                         <a:t>Ref.</a:t>
                       </a:r>
                     </a:p>
@@ -14502,10 +14786,18 @@
                         <a:buNone/>
                       </a:pPr>
                       <a:r>
-                        <a:rPr lang="en-US" sz="800" dirty="0"/>
+                        <a:rPr lang="en-US" sz="1200" dirty="0">
+                          <a:solidFill>
+                            <a:schemeClr val="bg2"/>
+                          </a:solidFill>
+                        </a:rPr>
                         <a:t>6</a:t>
                       </a:r>
-                      <a:endParaRPr lang="en-IN" sz="800" dirty="0"/>
+                      <a:endParaRPr lang="en-IN" sz="1200" dirty="0">
+                        <a:solidFill>
+                          <a:schemeClr val="bg2"/>
+                        </a:solidFill>
+                      </a:endParaRPr>
                     </a:p>
                   </a:txBody>
                   <a:tcPr marL="18367" marR="18367" marT="9184" marB="9184" anchor="ctr">
@@ -14557,7 +14849,11 @@
                         <a:buNone/>
                       </a:pPr>
                       <a:r>
-                        <a:rPr lang="en-IN" sz="800" dirty="0"/>
+                        <a:rPr lang="en-IN" sz="1200" dirty="0">
+                          <a:solidFill>
+                            <a:schemeClr val="bg2"/>
+                          </a:solidFill>
+                        </a:rPr>
                         <a:t>Large Language Models for Video Surveillance Applications</a:t>
                       </a:r>
                     </a:p>
@@ -14611,7 +14907,11 @@
                         <a:buNone/>
                       </a:pPr>
                       <a:r>
-                        <a:rPr lang="en-IN" sz="800"/>
+                        <a:rPr lang="en-IN" sz="1200">
+                          <a:solidFill>
+                            <a:schemeClr val="bg2"/>
+                          </a:solidFill>
+                        </a:rPr>
                         <a:t>MSR-VTT, CCTV</a:t>
                       </a:r>
                     </a:p>
@@ -14665,7 +14965,11 @@
                         <a:buNone/>
                       </a:pPr>
                       <a:r>
-                        <a:rPr lang="en-IN" sz="800" dirty="0"/>
+                        <a:rPr lang="en-IN" sz="1200" dirty="0">
+                          <a:solidFill>
+                            <a:schemeClr val="bg2"/>
+                          </a:solidFill>
+                        </a:rPr>
                         <a:t>Gemini Pro Vision (VLM)</a:t>
                       </a:r>
                     </a:p>
@@ -14719,7 +15023,11 @@
                         <a:buNone/>
                       </a:pPr>
                       <a:r>
-                        <a:rPr lang="en-US" sz="800"/>
+                        <a:rPr lang="en-US" sz="1200">
+                          <a:solidFill>
+                            <a:schemeClr val="bg2"/>
+                          </a:solidFill>
+                        </a:rPr>
                         <a:t>Shows VLMs can generate reliable CCTV summaries; heavy for edge deployment but useful for high-level reasoning</a:t>
                       </a:r>
                     </a:p>
@@ -14773,12 +15081,25 @@
                         <a:buNone/>
                       </a:pPr>
                       <a:r>
-                        <a:rPr lang="en-US" sz="800" dirty="0">
-                          <a:hlinkClick r:id="rId2" action="ppaction://hlinksldjump"/>
+                        <a:rPr lang="en-US" sz="1200" dirty="0">
+                          <a:solidFill>
+                            <a:schemeClr val="bg2"/>
+                          </a:solidFill>
+                          <a:hlinkClick r:id="rId2" action="ppaction://hlinksldjump">
+                            <a:extLst>
+                              <a:ext uri="{A12FA001-AC4F-418D-AE19-62706E023703}">
+                                <ahyp:hlinkClr xmlns:ahyp="http://schemas.microsoft.com/office/drawing/2018/hyperlinkcolor" val="tx"/>
+                              </a:ext>
+                            </a:extLst>
+                          </a:hlinkClick>
                         </a:rPr>
                         <a:t>[1]</a:t>
                       </a:r>
-                      <a:endParaRPr lang="en-IN" sz="800" dirty="0"/>
+                      <a:endParaRPr lang="en-IN" sz="1200" dirty="0">
+                        <a:solidFill>
+                          <a:schemeClr val="bg2"/>
+                        </a:solidFill>
+                      </a:endParaRPr>
                     </a:p>
                   </a:txBody>
                   <a:tcPr marL="18367" marR="18367" marT="9184" marB="9184" anchor="ctr">
@@ -14837,10 +15158,18 @@
                         <a:buNone/>
                       </a:pPr>
                       <a:r>
-                        <a:rPr lang="en-US" sz="800" dirty="0"/>
+                        <a:rPr lang="en-US" sz="1200" dirty="0">
+                          <a:solidFill>
+                            <a:schemeClr val="bg2"/>
+                          </a:solidFill>
+                        </a:rPr>
                         <a:t>7</a:t>
                       </a:r>
-                      <a:endParaRPr lang="en-IN" sz="800" dirty="0"/>
+                      <a:endParaRPr lang="en-IN" sz="1200" dirty="0">
+                        <a:solidFill>
+                          <a:schemeClr val="bg2"/>
+                        </a:solidFill>
+                      </a:endParaRPr>
                     </a:p>
                   </a:txBody>
                   <a:tcPr marL="18367" marR="18367" marT="9184" marB="9184" anchor="ctr">
@@ -14892,7 +15221,11 @@
                         <a:buNone/>
                       </a:pPr>
                       <a:r>
-                        <a:rPr lang="en-IN" sz="800"/>
+                        <a:rPr lang="en-IN" sz="1200">
+                          <a:solidFill>
+                            <a:schemeClr val="bg2"/>
+                          </a:solidFill>
+                        </a:rPr>
                         <a:t>ChatLR: Structured DB Retrieval via LLMs</a:t>
                       </a:r>
                     </a:p>
@@ -14946,11 +15279,19 @@
                         <a:buNone/>
                       </a:pPr>
                       <a:r>
-                        <a:rPr lang="en-IN" sz="800" dirty="0" err="1"/>
+                        <a:rPr lang="en-IN" sz="1200" dirty="0" err="1">
+                          <a:solidFill>
+                            <a:schemeClr val="bg2"/>
+                          </a:solidFill>
+                        </a:rPr>
                         <a:t>FinChina</a:t>
                       </a:r>
                       <a:r>
-                        <a:rPr lang="en-IN" sz="800" dirty="0"/>
+                        <a:rPr lang="en-IN" sz="1200" dirty="0">
+                          <a:solidFill>
+                            <a:schemeClr val="bg2"/>
+                          </a:solidFill>
+                        </a:rPr>
                         <a:t> SQL DB</a:t>
                       </a:r>
                     </a:p>
@@ -15004,7 +15345,11 @@
                         <a:buNone/>
                       </a:pPr>
                       <a:r>
-                        <a:rPr lang="en-IN" sz="800"/>
+                        <a:rPr lang="en-IN" sz="1200">
+                          <a:solidFill>
+                            <a:schemeClr val="bg2"/>
+                          </a:solidFill>
+                        </a:rPr>
                         <a:t>ChatGLM (LLM)</a:t>
                       </a:r>
                     </a:p>
@@ -15058,7 +15403,11 @@
                         <a:buNone/>
                       </a:pPr>
                       <a:r>
-                        <a:rPr lang="en-US" sz="800" dirty="0"/>
+                        <a:rPr lang="en-US" sz="1200" dirty="0">
+                          <a:solidFill>
+                            <a:schemeClr val="bg2"/>
+                          </a:solidFill>
+                        </a:rPr>
                         <a:t>LLMs can map natural-language queries to structured operations, enabling forensic querying on event logs</a:t>
                       </a:r>
                     </a:p>
@@ -15112,18 +15461,40 @@
                         <a:buNone/>
                       </a:pPr>
                       <a:r>
-                        <a:rPr lang="en-US" sz="800" dirty="0">
-                          <a:hlinkClick r:id="rId2" action="ppaction://hlinksldjump"/>
+                        <a:rPr lang="en-US" sz="1200" dirty="0">
+                          <a:solidFill>
+                            <a:srgbClr val="0097A7"/>
+                          </a:solidFill>
+                          <a:hlinkClick r:id="rId2" action="ppaction://hlinksldjump">
+                            <a:extLst>
+                              <a:ext uri="{A12FA001-AC4F-418D-AE19-62706E023703}">
+                                <ahyp:hlinkClr xmlns:ahyp="http://schemas.microsoft.com/office/drawing/2018/hyperlinkcolor" val="tx"/>
+                              </a:ext>
+                            </a:extLst>
+                          </a:hlinkClick>
                         </a:rPr>
                         <a:t>[6</a:t>
                       </a:r>
                       <a:r>
-                        <a:rPr lang="en-IN" sz="800" dirty="0">
-                          <a:hlinkClick r:id="rId2" action="ppaction://hlinksldjump"/>
+                        <a:rPr lang="en-IN" sz="1200" dirty="0">
+                          <a:solidFill>
+                            <a:schemeClr val="bg2"/>
+                          </a:solidFill>
+                          <a:hlinkClick r:id="rId2" action="ppaction://hlinksldjump">
+                            <a:extLst>
+                              <a:ext uri="{A12FA001-AC4F-418D-AE19-62706E023703}">
+                                <ahyp:hlinkClr xmlns:ahyp="http://schemas.microsoft.com/office/drawing/2018/hyperlinkcolor" val="tx"/>
+                              </a:ext>
+                            </a:extLst>
+                          </a:hlinkClick>
                         </a:rPr>
                         <a:t>]</a:t>
                       </a:r>
-                      <a:endParaRPr lang="en-IN" sz="800" dirty="0"/>
+                      <a:endParaRPr lang="en-IN" sz="1200" dirty="0">
+                        <a:solidFill>
+                          <a:schemeClr val="bg2"/>
+                        </a:solidFill>
+                      </a:endParaRPr>
                     </a:p>
                   </a:txBody>
                   <a:tcPr marL="18367" marR="18367" marT="9184" marB="9184" anchor="ctr">
@@ -15182,10 +15553,18 @@
                         <a:buNone/>
                       </a:pPr>
                       <a:r>
-                        <a:rPr lang="en-US" sz="800" dirty="0"/>
+                        <a:rPr lang="en-US" sz="1200" dirty="0">
+                          <a:solidFill>
+                            <a:schemeClr val="bg2"/>
+                          </a:solidFill>
+                        </a:rPr>
                         <a:t>8</a:t>
                       </a:r>
-                      <a:endParaRPr lang="en-IN" sz="800" dirty="0"/>
+                      <a:endParaRPr lang="en-IN" sz="1200" dirty="0">
+                        <a:solidFill>
+                          <a:schemeClr val="bg2"/>
+                        </a:solidFill>
+                      </a:endParaRPr>
                     </a:p>
                   </a:txBody>
                   <a:tcPr marL="18367" marR="18367" marT="9184" marB="9184" anchor="ctr">
@@ -15237,7 +15616,11 @@
                         <a:buNone/>
                       </a:pPr>
                       <a:r>
-                        <a:rPr lang="en-IN" sz="800" dirty="0"/>
+                        <a:rPr lang="en-IN" sz="1200" dirty="0">
+                          <a:solidFill>
+                            <a:schemeClr val="bg2"/>
+                          </a:solidFill>
+                        </a:rPr>
                         <a:t>HyST Hybrid Retrieval</a:t>
                       </a:r>
                     </a:p>
@@ -15291,7 +15674,11 @@
                         <a:buNone/>
                       </a:pPr>
                       <a:r>
-                        <a:rPr lang="en-IN" sz="800"/>
+                        <a:rPr lang="en-IN" sz="1200">
+                          <a:solidFill>
+                            <a:schemeClr val="bg2"/>
+                          </a:solidFill>
+                        </a:rPr>
                         <a:t>Amazon STaRK Dataset</a:t>
                       </a:r>
                     </a:p>
@@ -15345,7 +15732,11 @@
                         <a:buNone/>
                       </a:pPr>
                       <a:r>
-                        <a:rPr lang="en-IN" sz="800"/>
+                        <a:rPr lang="en-IN" sz="1200">
+                          <a:solidFill>
+                            <a:schemeClr val="bg2"/>
+                          </a:solidFill>
+                        </a:rPr>
                         <a:t>LLM + Hybrid Search</a:t>
                       </a:r>
                     </a:p>
@@ -15399,7 +15790,11 @@
                         <a:buNone/>
                       </a:pPr>
                       <a:r>
-                        <a:rPr lang="en-US" sz="800"/>
+                        <a:rPr lang="en-US" sz="1200">
+                          <a:solidFill>
+                            <a:schemeClr val="bg2"/>
+                          </a:solidFill>
+                        </a:rPr>
                         <a:t>Shows LLMs can handle semi-structured tables similar to CCTV logs</a:t>
                       </a:r>
                     </a:p>
@@ -15453,18 +15848,40 @@
                         <a:buNone/>
                       </a:pPr>
                       <a:r>
-                        <a:rPr lang="en-US" sz="800" dirty="0">
-                          <a:hlinkClick r:id="rId2" action="ppaction://hlinksldjump"/>
+                        <a:rPr lang="en-US" sz="1200" dirty="0">
+                          <a:solidFill>
+                            <a:srgbClr val="0097A7"/>
+                          </a:solidFill>
+                          <a:hlinkClick r:id="rId2" action="ppaction://hlinksldjump">
+                            <a:extLst>
+                              <a:ext uri="{A12FA001-AC4F-418D-AE19-62706E023703}">
+                                <ahyp:hlinkClr xmlns:ahyp="http://schemas.microsoft.com/office/drawing/2018/hyperlinkcolor" val="tx"/>
+                              </a:ext>
+                            </a:extLst>
+                          </a:hlinkClick>
                         </a:rPr>
                         <a:t>[7</a:t>
                       </a:r>
                       <a:r>
-                        <a:rPr lang="en-IN" sz="800" dirty="0">
-                          <a:hlinkClick r:id="rId2" action="ppaction://hlinksldjump"/>
+                        <a:rPr lang="en-IN" sz="1200" dirty="0">
+                          <a:solidFill>
+                            <a:schemeClr val="bg2"/>
+                          </a:solidFill>
+                          <a:hlinkClick r:id="rId2" action="ppaction://hlinksldjump">
+                            <a:extLst>
+                              <a:ext uri="{A12FA001-AC4F-418D-AE19-62706E023703}">
+                                <ahyp:hlinkClr xmlns:ahyp="http://schemas.microsoft.com/office/drawing/2018/hyperlinkcolor" val="tx"/>
+                              </a:ext>
+                            </a:extLst>
+                          </a:hlinkClick>
                         </a:rPr>
                         <a:t>]</a:t>
                       </a:r>
-                      <a:endParaRPr lang="en-IN" sz="800" dirty="0"/>
+                      <a:endParaRPr lang="en-IN" sz="1200" dirty="0">
+                        <a:solidFill>
+                          <a:schemeClr val="bg2"/>
+                        </a:solidFill>
+                      </a:endParaRPr>
                     </a:p>
                   </a:txBody>
                   <a:tcPr marL="18367" marR="18367" marT="9184" marB="9184" anchor="ctr">
@@ -15523,10 +15940,18 @@
                         <a:buNone/>
                       </a:pPr>
                       <a:r>
-                        <a:rPr lang="en-US" sz="800" dirty="0"/>
+                        <a:rPr lang="en-US" sz="1200" dirty="0">
+                          <a:solidFill>
+                            <a:schemeClr val="bg2"/>
+                          </a:solidFill>
+                        </a:rPr>
                         <a:t>9</a:t>
                       </a:r>
-                      <a:endParaRPr lang="en-IN" sz="800" dirty="0"/>
+                      <a:endParaRPr lang="en-IN" sz="1200" dirty="0">
+                        <a:solidFill>
+                          <a:schemeClr val="bg2"/>
+                        </a:solidFill>
+                      </a:endParaRPr>
                     </a:p>
                   </a:txBody>
                   <a:tcPr marL="18367" marR="18367" marT="9184" marB="9184" anchor="ctr">
@@ -15578,7 +16003,11 @@
                         <a:buNone/>
                       </a:pPr>
                       <a:r>
-                        <a:rPr lang="en-IN" sz="800"/>
+                        <a:rPr lang="en-IN" sz="1200">
+                          <a:solidFill>
+                            <a:schemeClr val="bg2"/>
+                          </a:solidFill>
+                        </a:rPr>
                         <a:t>StructuredRAG JSON Formatting</a:t>
                       </a:r>
                     </a:p>
@@ -15632,7 +16061,11 @@
                         <a:buNone/>
                       </a:pPr>
                       <a:r>
-                        <a:rPr lang="en-IN" sz="800"/>
+                        <a:rPr lang="en-IN" sz="1200">
+                          <a:solidFill>
+                            <a:schemeClr val="bg2"/>
+                          </a:solidFill>
+                        </a:rPr>
                         <a:t>JSON Benchmarks</a:t>
                       </a:r>
                     </a:p>
@@ -15686,7 +16119,11 @@
                         <a:buNone/>
                       </a:pPr>
                       <a:r>
-                        <a:rPr lang="en-IN" sz="800"/>
+                        <a:rPr lang="en-IN" sz="1200">
+                          <a:solidFill>
+                            <a:schemeClr val="bg2"/>
+                          </a:solidFill>
+                        </a:rPr>
                         <a:t>GPT, LLaMA</a:t>
                       </a:r>
                     </a:p>
@@ -15740,7 +16177,11 @@
                         <a:buNone/>
                       </a:pPr>
                       <a:r>
-                        <a:rPr lang="en-US" sz="800"/>
+                        <a:rPr lang="en-US" sz="1200">
+                          <a:solidFill>
+                            <a:schemeClr val="bg2"/>
+                          </a:solidFill>
+                        </a:rPr>
                         <a:t>Evaluates LLM structured-output reliability; informs structured insight generation design</a:t>
                       </a:r>
                     </a:p>
@@ -15794,12 +16235,25 @@
                         <a:buNone/>
                       </a:pPr>
                       <a:r>
-                        <a:rPr lang="en-US" sz="800" dirty="0">
-                          <a:hlinkClick r:id="rId3" action="ppaction://hlinksldjump"/>
+                        <a:rPr lang="en-US" sz="1200" dirty="0">
+                          <a:solidFill>
+                            <a:schemeClr val="bg2"/>
+                          </a:solidFill>
+                          <a:hlinkClick r:id="rId3" action="ppaction://hlinksldjump">
+                            <a:extLst>
+                              <a:ext uri="{A12FA001-AC4F-418D-AE19-62706E023703}">
+                                <ahyp:hlinkClr xmlns:ahyp="http://schemas.microsoft.com/office/drawing/2018/hyperlinkcolor" val="tx"/>
+                              </a:ext>
+                            </a:extLst>
+                          </a:hlinkClick>
                         </a:rPr>
                         <a:t>[8]</a:t>
                       </a:r>
-                      <a:endParaRPr lang="en-IN" sz="800" dirty="0"/>
+                      <a:endParaRPr lang="en-IN" sz="1200" dirty="0">
+                        <a:solidFill>
+                          <a:schemeClr val="bg2"/>
+                        </a:solidFill>
+                      </a:endParaRPr>
                     </a:p>
                   </a:txBody>
                   <a:tcPr marL="18367" marR="18367" marT="9184" marB="9184" anchor="ctr">
@@ -15848,7 +16302,7 @@
                   </a:ext>
                 </a:extLst>
               </a:tr>
-              <a:tr h="480733">
+              <a:tr h="365477">
                 <a:tc>
                   <a:txBody>
                     <a:bodyPr/>
@@ -15858,11 +16312,19 @@
                         <a:buNone/>
                       </a:pPr>
                       <a:r>
-                        <a:rPr lang="en-US" sz="800" dirty="0"/>
+                        <a:rPr lang="en-US" sz="1200" dirty="0">
+                          <a:solidFill>
+                            <a:schemeClr val="bg2"/>
+                          </a:solidFill>
+                        </a:rPr>
                         <a:t>1</a:t>
                       </a:r>
                       <a:r>
-                        <a:rPr lang="en-IN" sz="800" dirty="0"/>
+                        <a:rPr lang="en-IN" sz="1200" dirty="0">
+                          <a:solidFill>
+                            <a:schemeClr val="bg2"/>
+                          </a:solidFill>
+                        </a:rPr>
                         <a:t>0</a:t>
                       </a:r>
                     </a:p>
@@ -15916,7 +16378,11 @@
                         <a:buNone/>
                       </a:pPr>
                       <a:r>
-                        <a:rPr lang="en-IN" sz="800"/>
+                        <a:rPr lang="en-IN" sz="1200">
+                          <a:solidFill>
+                            <a:schemeClr val="bg2"/>
+                          </a:solidFill>
+                        </a:rPr>
                         <a:t>LLM-based Log Analysis Survey</a:t>
                       </a:r>
                     </a:p>
@@ -15970,7 +16436,11 @@
                         <a:buNone/>
                       </a:pPr>
                       <a:r>
-                        <a:rPr lang="en-IN" sz="800"/>
+                        <a:rPr lang="en-IN" sz="1200">
+                          <a:solidFill>
+                            <a:schemeClr val="bg2"/>
+                          </a:solidFill>
+                        </a:rPr>
                         <a:t>Various Log Corpora</a:t>
                       </a:r>
                     </a:p>
@@ -16024,7 +16494,11 @@
                         <a:buNone/>
                       </a:pPr>
                       <a:r>
-                        <a:rPr lang="en-IN" sz="800"/>
+                        <a:rPr lang="en-IN" sz="1200">
+                          <a:solidFill>
+                            <a:schemeClr val="bg2"/>
+                          </a:solidFill>
+                        </a:rPr>
                         <a:t>LLMs (RAG, Fine-Tuning)</a:t>
                       </a:r>
                     </a:p>
@@ -16078,7 +16552,11 @@
                         <a:buNone/>
                       </a:pPr>
                       <a:r>
-                        <a:rPr lang="en-US" sz="800"/>
+                        <a:rPr lang="en-US" sz="1200">
+                          <a:solidFill>
+                            <a:schemeClr val="bg2"/>
+                          </a:solidFill>
+                        </a:rPr>
                         <a:t>LLMs reduce manual log-review effort and surface hidden patterns</a:t>
                       </a:r>
                     </a:p>
@@ -16132,12 +16610,25 @@
                         <a:buNone/>
                       </a:pPr>
                       <a:r>
-                        <a:rPr lang="en-US" sz="800" dirty="0">
-                          <a:hlinkClick r:id="rId3" action="ppaction://hlinksldjump"/>
+                        <a:rPr lang="en-US" sz="1200" dirty="0">
+                          <a:solidFill>
+                            <a:schemeClr val="bg2"/>
+                          </a:solidFill>
+                          <a:hlinkClick r:id="rId3" action="ppaction://hlinksldjump">
+                            <a:extLst>
+                              <a:ext uri="{A12FA001-AC4F-418D-AE19-62706E023703}">
+                                <ahyp:hlinkClr xmlns:ahyp="http://schemas.microsoft.com/office/drawing/2018/hyperlinkcolor" val="tx"/>
+                              </a:ext>
+                            </a:extLst>
+                          </a:hlinkClick>
                         </a:rPr>
                         <a:t>[9]</a:t>
                       </a:r>
-                      <a:endParaRPr lang="en-IN" sz="800" dirty="0"/>
+                      <a:endParaRPr lang="en-IN" sz="1200" dirty="0">
+                        <a:solidFill>
+                          <a:schemeClr val="bg2"/>
+                        </a:solidFill>
+                      </a:endParaRPr>
                     </a:p>
                   </a:txBody>
                   <a:tcPr marL="18367" marR="18367" marT="9184" marB="9184" anchor="ctr">
@@ -16267,10 +16758,10 @@
               <a:buNone/>
             </a:pPr>
             <a:r>
-              <a:rPr lang="en-GB" dirty="0"/>
+              <a:rPr lang="en-GB" sz="3100" b="1" dirty="0"/>
               <a:t>Literature Review</a:t>
             </a:r>
-            <a:endParaRPr dirty="0"/>
+            <a:endParaRPr sz="3100" b="1" dirty="0"/>
           </a:p>
           <a:p>
             <a:pPr marL="0" lvl="0" indent="0" algn="l" rtl="0">
@@ -16460,15 +16951,15 @@
         <p:spPr/>
         <p:txBody>
           <a:bodyPr>
-            <a:normAutofit fontScale="90000"/>
+            <a:noAutofit/>
           </a:bodyPr>
           <a:lstStyle/>
           <a:p>
             <a:r>
-              <a:rPr lang="en-GB" dirty="0"/>
+              <a:rPr lang="en-GB" b="1" dirty="0"/>
               <a:t>Literature Review</a:t>
             </a:r>
-            <a:endParaRPr lang="en-IN" dirty="0"/>
+            <a:endParaRPr lang="en-IN" b="1" dirty="0"/>
           </a:p>
         </p:txBody>
       </p:sp>
@@ -16502,7 +16993,7 @@
               <a:buNone/>
             </a:pPr>
             <a:r>
-              <a:rPr lang="en-US" sz="1500" b="1" dirty="0"/>
+              <a:rPr lang="en-US" b="1" dirty="0"/>
               <a:t>Summary</a:t>
             </a:r>
           </a:p>
@@ -16514,7 +17005,7 @@
               <a:buNone/>
             </a:pPr>
             <a:r>
-              <a:rPr lang="en-US" sz="1400" dirty="0"/>
+              <a:rPr lang="en-US" dirty="0"/>
               <a:t>Combined, these papers validate our architecture:</a:t>
             </a:r>
           </a:p>
@@ -16525,11 +17016,11 @@
               </a:lnSpc>
             </a:pPr>
             <a:r>
-              <a:rPr lang="en-US" sz="1400" b="1" dirty="0"/>
+              <a:rPr lang="en-US" b="1" dirty="0"/>
               <a:t>CV extracts events</a:t>
             </a:r>
             <a:r>
-              <a:rPr lang="en-US" sz="1400" dirty="0"/>
+              <a:rPr lang="en-US" dirty="0"/>
               <a:t>,</a:t>
             </a:r>
           </a:p>
@@ -16540,18 +17031,18 @@
               </a:lnSpc>
             </a:pPr>
             <a:r>
-              <a:rPr lang="en-US" sz="1400" b="1" dirty="0"/>
+              <a:rPr lang="en-US" b="1" dirty="0"/>
               <a:t>LLM performs reasoning and insight generation</a:t>
             </a:r>
             <a:r>
-              <a:rPr lang="en-US" sz="1400" dirty="0"/>
+              <a:rPr lang="en-US" dirty="0"/>
               <a:t>,</a:t>
             </a:r>
             <a:br>
-              <a:rPr lang="en-US" sz="1400" dirty="0"/>
+              <a:rPr lang="en-US" dirty="0"/>
             </a:br>
             <a:r>
-              <a:rPr lang="en-US" sz="1400" dirty="0"/>
+              <a:rPr lang="en-US" dirty="0"/>
               <a:t>which is the main focus of the project.</a:t>
             </a:r>
           </a:p>
@@ -16608,7 +17099,7 @@
         </p:spPr>
         <p:txBody>
           <a:bodyPr spcFirstLastPara="1" wrap="square" lIns="91425" tIns="91425" rIns="91425" bIns="91425" anchor="t" anchorCtr="0">
-            <a:normAutofit fontScale="90000"/>
+            <a:noAutofit/>
           </a:bodyPr>
           <a:lstStyle/>
           <a:p>
@@ -16622,10 +17113,10 @@
               <a:buNone/>
             </a:pPr>
             <a:r>
-              <a:rPr lang="en-GB" dirty="0"/>
+              <a:rPr lang="en-GB" b="1" dirty="0"/>
               <a:t>System Flow Diagram</a:t>
             </a:r>
-            <a:endParaRPr dirty="0"/>
+            <a:endParaRPr b="1" dirty="0"/>
           </a:p>
           <a:p>
             <a:pPr marL="0" lvl="0" indent="0" algn="l" rtl="0">
@@ -16637,7 +17128,7 @@
               </a:spcAft>
               <a:buNone/>
             </a:pPr>
-            <a:endParaRPr dirty="0"/>
+            <a:endParaRPr b="1" dirty="0"/>
           </a:p>
           <a:p>
             <a:pPr marL="0" lvl="0" indent="0" algn="l" rtl="0">
@@ -16649,7 +17140,7 @@
               </a:spcAft>
               <a:buNone/>
             </a:pPr>
-            <a:endParaRPr dirty="0"/>
+            <a:endParaRPr b="1" dirty="0"/>
           </a:p>
         </p:txBody>
       </p:sp>
@@ -16775,15 +17266,15 @@
         <p:spPr/>
         <p:txBody>
           <a:bodyPr>
-            <a:normAutofit fontScale="90000"/>
+            <a:noAutofit/>
           </a:bodyPr>
           <a:lstStyle/>
           <a:p>
             <a:r>
-              <a:rPr lang="en-GB" dirty="0"/>
+              <a:rPr lang="en-GB" b="1" dirty="0"/>
               <a:t>System Flow Overview</a:t>
             </a:r>
-            <a:endParaRPr lang="en-IN" dirty="0"/>
+            <a:endParaRPr lang="en-IN" b="1" dirty="0"/>
           </a:p>
         </p:txBody>
       </p:sp>
@@ -16801,8 +17292,8 @@
         </p:nvSpPr>
         <p:spPr>
           <a:xfrm>
-            <a:off x="446049" y="1338146"/>
-            <a:ext cx="7092175" cy="3858300"/>
+            <a:off x="379141" y="1017725"/>
+            <a:ext cx="8184996" cy="4360424"/>
           </a:xfrm>
           <a:prstGeom prst="rect">
             <a:avLst/>
@@ -16821,14 +17312,14 @@
               </a:lnSpc>
             </a:pPr>
             <a:r>
-              <a:rPr lang="en-US" sz="1500" b="1" dirty="0">
+              <a:rPr lang="en-US" sz="1700" b="1" dirty="0">
                 <a:solidFill>
                   <a:schemeClr val="bg2"/>
                 </a:solidFill>
               </a:rPr>
               <a:t>1. CCTV Perception Layer</a:t>
             </a:r>
-            <a:endParaRPr lang="en-US" sz="1500" dirty="0">
+            <a:endParaRPr lang="en-US" sz="1700" dirty="0">
               <a:solidFill>
                 <a:schemeClr val="bg2"/>
               </a:solidFill>
@@ -16841,7 +17332,7 @@
               </a:lnSpc>
             </a:pPr>
             <a:r>
-              <a:rPr lang="en-US" sz="1500" dirty="0">
+              <a:rPr lang="en-US" sz="1700" dirty="0">
                 <a:solidFill>
                   <a:schemeClr val="bg2"/>
                 </a:solidFill>
@@ -16856,7 +17347,7 @@
               </a:lnSpc>
             </a:pPr>
             <a:r>
-              <a:rPr lang="en-US" sz="1500" dirty="0">
+              <a:rPr lang="en-US" sz="1700" dirty="0">
                 <a:solidFill>
                   <a:schemeClr val="bg2"/>
                 </a:solidFill>
@@ -16870,7 +17361,7 @@
                 <a:spcPct val="150000"/>
               </a:lnSpc>
             </a:pPr>
-            <a:endParaRPr lang="en-US" sz="1500" dirty="0">
+            <a:endParaRPr lang="en-US" sz="1700" dirty="0">
               <a:solidFill>
                 <a:schemeClr val="bg2"/>
               </a:solidFill>
@@ -16883,14 +17374,14 @@
               </a:lnSpc>
             </a:pPr>
             <a:r>
-              <a:rPr lang="en-US" sz="1500" b="1" dirty="0">
+              <a:rPr lang="en-US" sz="1700" b="1" dirty="0">
                 <a:solidFill>
                   <a:schemeClr val="bg2"/>
                 </a:solidFill>
               </a:rPr>
               <a:t>2. Local Event Processing</a:t>
             </a:r>
-            <a:endParaRPr lang="en-US" sz="1500" dirty="0">
+            <a:endParaRPr lang="en-US" sz="1700" dirty="0">
               <a:solidFill>
                 <a:schemeClr val="bg2"/>
               </a:solidFill>
@@ -16903,7 +17394,7 @@
               </a:lnSpc>
             </a:pPr>
             <a:r>
-              <a:rPr lang="en-US" sz="1500" dirty="0">
+              <a:rPr lang="en-US" sz="1700" dirty="0">
                 <a:solidFill>
                   <a:schemeClr val="bg2"/>
                 </a:solidFill>
@@ -16911,14 +17402,14 @@
               <a:t>Detected objects are passed to an event classification module</a:t>
             </a:r>
             <a:br>
-              <a:rPr lang="en-US" sz="1500" dirty="0">
+              <a:rPr lang="en-US" sz="1700" dirty="0">
                 <a:solidFill>
                   <a:schemeClr val="bg2"/>
                 </a:solidFill>
               </a:rPr>
             </a:br>
             <a:r>
-              <a:rPr lang="en-US" sz="1500" dirty="0">
+              <a:rPr lang="en-US" sz="1700" dirty="0">
                 <a:solidFill>
                   <a:schemeClr val="bg2"/>
                 </a:solidFill>
@@ -16933,7 +17424,7 @@
               </a:lnSpc>
             </a:pPr>
             <a:r>
-              <a:rPr lang="en-US" sz="1500" dirty="0">
+              <a:rPr lang="en-US" sz="1700" dirty="0">
                 <a:solidFill>
                   <a:schemeClr val="bg2"/>
                 </a:solidFill>
@@ -16941,14 +17432,14 @@
               <a:t>A structured JSON log generator converts detections into clean event records</a:t>
             </a:r>
             <a:br>
-              <a:rPr lang="en-US" sz="1500" dirty="0">
+              <a:rPr lang="en-US" sz="1700" dirty="0">
                 <a:solidFill>
                   <a:schemeClr val="bg2"/>
                 </a:solidFill>
               </a:rPr>
             </a:br>
             <a:r>
-              <a:rPr lang="en-US" sz="1500" i="1" dirty="0">
+              <a:rPr lang="en-US" sz="1700" i="1" dirty="0">
                 <a:solidFill>
                   <a:schemeClr val="bg2"/>
                 </a:solidFill>
@@ -16956,7 +17447,7 @@
               <a:t>(timestamp, camera ID, event type, confidence, object ID, location)</a:t>
             </a:r>
             <a:r>
-              <a:rPr lang="en-US" sz="1500" dirty="0">
+              <a:rPr lang="en-US" sz="1700" dirty="0">
                 <a:solidFill>
                   <a:schemeClr val="bg2"/>
                 </a:solidFill>
@@ -16970,7 +17461,7 @@
                 <a:spcPct val="150000"/>
               </a:lnSpc>
             </a:pPr>
-            <a:endParaRPr lang="en-IN" sz="1500" dirty="0">
+            <a:endParaRPr lang="en-IN" sz="1700" dirty="0">
               <a:solidFill>
                 <a:schemeClr val="bg2"/>
               </a:solidFill>

</xml_diff>